<commit_message>
chore: week12, week13 juwon 폴더 삭제
Co-Authored-By: Claude Sonnet 4.6 <noreply@anthropic.com>
</commit_message>
<xml_diff>
--- a/week10-self-correction/juwon/week10_발표.pptx
+++ b/week10-self-correction/juwon/week10_발표.pptx
@@ -14,6 +14,7 @@
     <p:sldId id="262" r:id="rId13"/>
     <p:sldId id="263" r:id="rId14"/>
     <p:sldId id="264" r:id="rId15"/>
+    <p:sldId id="265" r:id="rId16"/>
   </p:sldIdLst>
   <p:sldSz cx="9144000" cy="5143500" type="screen4x3"/>
   <p:notesSz cx="6858000" cy="9144000"/>
@@ -3147,7 +3148,7 @@
         </p:nvSpPr>
         <p:spPr>
           <a:xfrm>
-            <a:off x="457200" y="731520"/>
+            <a:off x="457200" y="822960"/>
             <a:ext cx="8229600" cy="457200"/>
           </a:xfrm>
           <a:prstGeom prst="rect">
@@ -3180,7 +3181,7 @@
         </p:nvSpPr>
         <p:spPr>
           <a:xfrm>
-            <a:off x="457200" y="1188720"/>
+            <a:off x="457200" y="1280160"/>
             <a:ext cx="8229600" cy="914400"/>
           </a:xfrm>
           <a:prstGeom prst="rect">
@@ -3213,7 +3214,7 @@
         </p:nvSpPr>
         <p:spPr>
           <a:xfrm>
-            <a:off x="457200" y="2103120"/>
+            <a:off x="457200" y="2286000"/>
             <a:ext cx="8229600" cy="548640"/>
           </a:xfrm>
           <a:prstGeom prst="rect">
@@ -3233,7 +3234,7 @@
                   <a:srgbClr val="FFFFFF"/>
                 </a:solidFill>
               </a:rPr>
-              <a:t>결과 검토 및 수정 로직 (Reflection)</a:t>
+              <a:t>AI가 쓴 보고서가 별로면 다시 쓰게 하는 기능</a:t>
             </a:r>
           </a:p>
         </p:txBody>
@@ -3246,7 +3247,7 @@
         </p:nvSpPr>
         <p:spPr>
           <a:xfrm>
-            <a:off x="457200" y="2651760"/>
+            <a:off x="457200" y="2926080"/>
             <a:ext cx="8229600" cy="457200"/>
           </a:xfrm>
           <a:prstGeom prst="rect">
@@ -3261,12 +3262,12 @@
           <a:lstStyle/>
           <a:p>
             <a:r>
-              <a:rPr sz="1600" b="0">
+              <a:rPr sz="1500" b="0">
                 <a:solidFill>
                   <a:srgbClr val="8B949E"/>
                 </a:solidFill>
               </a:rPr>
-              <a:t>틀린 결과 시 재검색/수정하는 루프 구현</a:t>
+              <a:t>GitHub 트렌드 수집  →  AI 분석  →  품질 검사  →  메일 + GitHub 자동 발송</a:t>
             </a:r>
           </a:p>
         </p:txBody>
@@ -3279,7 +3280,7 @@
         </p:nvSpPr>
         <p:spPr>
           <a:xfrm>
-            <a:off x="457200" y="3840480"/>
+            <a:off x="457200" y="4114800"/>
             <a:ext cx="8229600" cy="365760"/>
           </a:xfrm>
           <a:prstGeom prst="rect">
@@ -3294,7 +3295,7 @@
           <a:lstStyle/>
           <a:p>
             <a:r>
-              <a:rPr sz="1400" b="0">
+              <a:rPr sz="1300" b="0">
                 <a:solidFill>
                   <a:srgbClr val="3FB950"/>
                 </a:solidFill>
@@ -3304,16 +3305,155 @@
           </a:p>
         </p:txBody>
       </p:sp>
-      <p:sp>
-        <p:nvSpPr>
-          <p:cNvPr id="8" name="TextBox 7"/>
+    </p:spTree>
+  </p:cSld>
+  <p:clrMapOvr>
+    <a:masterClrMapping/>
+  </p:clrMapOvr>
+</p:sld>
+</file>
+
+<file path=ppt/slides/slide10.xml><?xml version="1.0" encoding="utf-8"?>
+<p:sld xmlns:a="http://schemas.openxmlformats.org/drawingml/2006/main" xmlns:p="http://schemas.openxmlformats.org/presentationml/2006/main" xmlns:r="http://schemas.openxmlformats.org/officeDocument/2006/relationships">
+  <p:cSld>
+    <p:spTree>
+      <p:nvGrpSpPr>
+        <p:cNvPr id="1" name=""/>
+        <p:cNvGrpSpPr/>
+        <p:nvPr/>
+      </p:nvGrpSpPr>
+      <p:grpSpPr/>
+      <p:sp>
+        <p:nvSpPr>
+          <p:cNvPr id="2" name="Rectangle 1"/>
+          <p:cNvSpPr/>
+          <p:nvPr/>
+        </p:nvSpPr>
+        <p:spPr>
+          <a:xfrm>
+            <a:off x="0" y="0"/>
+            <a:ext cx="9144000" cy="5143500"/>
+          </a:xfrm>
+          <a:prstGeom prst="rect">
+            <a:avLst/>
+          </a:prstGeom>
+          <a:solidFill>
+            <a:srgbClr val="0D1117"/>
+          </a:solidFill>
+          <a:ln>
+            <a:noFill/>
+          </a:ln>
+        </p:spPr>
+        <p:style>
+          <a:lnRef idx="1">
+            <a:schemeClr val="accent1"/>
+          </a:lnRef>
+          <a:fillRef idx="3">
+            <a:schemeClr val="accent1"/>
+          </a:fillRef>
+          <a:effectRef idx="2">
+            <a:schemeClr val="accent1"/>
+          </a:effectRef>
+          <a:fontRef idx="minor">
+            <a:schemeClr val="lt1"/>
+          </a:fontRef>
+        </p:style>
+        <p:txBody>
+          <a:bodyPr rtlCol="0" anchor="ctr"/>
+          <a:lstStyle/>
+          <a:p>
+            <a:pPr algn="ctr"/>
+          </a:p>
+        </p:txBody>
+      </p:sp>
+      <p:sp>
+        <p:nvSpPr>
+          <p:cNvPr id="3" name="TextBox 2"/>
           <p:cNvSpPr txBox="1"/>
           <p:nvPr/>
         </p:nvSpPr>
         <p:spPr>
           <a:xfrm>
-            <a:off x="457200" y="4297680"/>
-            <a:ext cx="8229600" cy="365760"/>
+            <a:off x="457200" y="274320"/>
+            <a:ext cx="8229600" cy="640080"/>
+          </a:xfrm>
+          <a:prstGeom prst="rect">
+            <a:avLst/>
+          </a:prstGeom>
+          <a:noFill/>
+        </p:spPr>
+        <p:txBody>
+          <a:bodyPr wrap="none">
+            <a:spAutoFit/>
+          </a:bodyPr>
+          <a:lstStyle/>
+          <a:p>
+            <a:r>
+              <a:rPr sz="2800" b="1">
+                <a:solidFill>
+                  <a:srgbClr val="58A6FF"/>
+                </a:solidFill>
+              </a:rPr>
+              <a:t>회고 &amp; 다음 주</a:t>
+            </a:r>
+          </a:p>
+        </p:txBody>
+      </p:sp>
+      <p:sp>
+        <p:nvSpPr>
+          <p:cNvPr id="4" name="Rectangle 3"/>
+          <p:cNvSpPr/>
+          <p:nvPr/>
+        </p:nvSpPr>
+        <p:spPr>
+          <a:xfrm>
+            <a:off x="274320" y="1005840"/>
+            <a:ext cx="8595360" cy="2560320"/>
+          </a:xfrm>
+          <a:prstGeom prst="rect">
+            <a:avLst/>
+          </a:prstGeom>
+          <a:solidFill>
+            <a:srgbClr val="161B22"/>
+          </a:solidFill>
+          <a:ln w="19050">
+            <a:solidFill>
+              <a:srgbClr val="58A6FF"/>
+            </a:solidFill>
+          </a:ln>
+        </p:spPr>
+        <p:style>
+          <a:lnRef idx="1">
+            <a:schemeClr val="accent1"/>
+          </a:lnRef>
+          <a:fillRef idx="3">
+            <a:schemeClr val="accent1"/>
+          </a:fillRef>
+          <a:effectRef idx="2">
+            <a:schemeClr val="accent1"/>
+          </a:effectRef>
+          <a:fontRef idx="minor">
+            <a:schemeClr val="lt1"/>
+          </a:fontRef>
+        </p:style>
+        <p:txBody>
+          <a:bodyPr rtlCol="0" anchor="ctr"/>
+          <a:lstStyle/>
+          <a:p>
+            <a:pPr algn="ctr"/>
+          </a:p>
+        </p:txBody>
+      </p:sp>
+      <p:sp>
+        <p:nvSpPr>
+          <p:cNvPr id="5" name="TextBox 4"/>
+          <p:cNvSpPr txBox="1"/>
+          <p:nvPr/>
+        </p:nvSpPr>
+        <p:spPr>
+          <a:xfrm>
+            <a:off x="384048" y="1097280"/>
+            <a:ext cx="8375904" cy="2423160"/>
           </a:xfrm>
           <a:prstGeom prst="rect">
             <a:avLst/>
@@ -3327,12 +3467,97 @@
           <a:lstStyle/>
           <a:p>
             <a:r>
-              <a:rPr sz="1200" b="0">
-                <a:solidFill>
-                  <a:srgbClr val="8B949E"/>
+              <a:rPr sz="1300">
+                <a:solidFill>
+                  <a:srgbClr val="FFFFFF"/>
                 </a:solidFill>
               </a:rPr>
-              <a:t>LangGraph · Self-Correction · Gmail · GitHub README</a:t>
+              <a:t>이번 주 배운 것
+• AI는 자기 결과가 좋은지 나쁜지 스스로 판단 못함
+• 사람이 기준을 코드로 정해놓으면 자동으로 품질이 올라감
+• 트렌드 수집(GitHub API)과 보고서 품질(Self-Correction)은 다른 문제
+• Gmail SMTP: 앱 비밀번호로 코드에서 직접 메일 발송 가능
+• GitHub API: 토큰만 있으면 파일 자동 생성/업데이트 가능</a:t>
+            </a:r>
+          </a:p>
+        </p:txBody>
+      </p:sp>
+      <p:sp>
+        <p:nvSpPr>
+          <p:cNvPr id="6" name="Rectangle 5"/>
+          <p:cNvSpPr/>
+          <p:nvPr/>
+        </p:nvSpPr>
+        <p:spPr>
+          <a:xfrm>
+            <a:off x="274320" y="3749039"/>
+            <a:ext cx="8595360" cy="1188720"/>
+          </a:xfrm>
+          <a:prstGeom prst="rect">
+            <a:avLst/>
+          </a:prstGeom>
+          <a:solidFill>
+            <a:srgbClr val="161B22"/>
+          </a:solidFill>
+          <a:ln w="19050">
+            <a:solidFill>
+              <a:srgbClr val="3FB950"/>
+            </a:solidFill>
+          </a:ln>
+        </p:spPr>
+        <p:style>
+          <a:lnRef idx="1">
+            <a:schemeClr val="accent1"/>
+          </a:lnRef>
+          <a:fillRef idx="3">
+            <a:schemeClr val="accent1"/>
+          </a:fillRef>
+          <a:effectRef idx="2">
+            <a:schemeClr val="accent1"/>
+          </a:effectRef>
+          <a:fontRef idx="minor">
+            <a:schemeClr val="lt1"/>
+          </a:fontRef>
+        </p:style>
+        <p:txBody>
+          <a:bodyPr rtlCol="0" anchor="ctr"/>
+          <a:lstStyle/>
+          <a:p>
+            <a:pPr algn="ctr"/>
+          </a:p>
+        </p:txBody>
+      </p:sp>
+      <p:sp>
+        <p:nvSpPr>
+          <p:cNvPr id="7" name="TextBox 6"/>
+          <p:cNvSpPr txBox="1"/>
+          <p:nvPr/>
+        </p:nvSpPr>
+        <p:spPr>
+          <a:xfrm>
+            <a:off x="384048" y="3840479"/>
+            <a:ext cx="8375904" cy="1051560"/>
+          </a:xfrm>
+          <a:prstGeom prst="rect">
+            <a:avLst/>
+          </a:prstGeom>
+          <a:noFill/>
+        </p:spPr>
+        <p:txBody>
+          <a:bodyPr wrap="square">
+            <a:spAutoFit/>
+          </a:bodyPr>
+          <a:lstStyle/>
+          <a:p>
+            <a:r>
+              <a:rPr sz="1300">
+                <a:solidFill>
+                  <a:srgbClr val="FFFFFF"/>
+                </a:solidFill>
+              </a:rPr>
+              <a:t>다음 주 (Week 11): Multi-Agent
+• 지금까지: 에이전트 1개가 혼자 다 함
+• 다음 주:  에이전트 여러 개가 역할 분담해서 협력</a:t>
             </a:r>
           </a:p>
         </p:txBody>
@@ -3426,21 +3651,541 @@
                   <a:srgbClr val="58A6FF"/>
                 </a:solidFill>
               </a:rPr>
-              <a:t>9주차 vs 10주차</a:t>
-            </a:r>
-          </a:p>
-        </p:txBody>
-      </p:sp>
-      <p:sp>
-        <p:nvSpPr>
-          <p:cNvPr id="4" name="Rectangle 3"/>
+              <a:t>10주차에서 만든 것</a:t>
+            </a:r>
+          </a:p>
+        </p:txBody>
+      </p:sp>
+      <p:sp>
+        <p:nvSpPr>
+          <p:cNvPr id="4" name="TextBox 3"/>
+          <p:cNvSpPr txBox="1"/>
+          <p:nvPr/>
+        </p:nvSpPr>
+        <p:spPr>
+          <a:xfrm>
+            <a:off x="457200" y="914400"/>
+            <a:ext cx="8229600" cy="731520"/>
+          </a:xfrm>
+          <a:prstGeom prst="rect">
+            <a:avLst/>
+          </a:prstGeom>
+          <a:noFill/>
+        </p:spPr>
+        <p:txBody>
+          <a:bodyPr wrap="square">
+            <a:spAutoFit/>
+          </a:bodyPr>
+          <a:lstStyle/>
+          <a:p>
+            <a:r>
+              <a:rPr sz="1400" b="0">
+                <a:solidFill>
+                  <a:srgbClr val="8B949E"/>
+                </a:solidFill>
+              </a:rPr>
+              <a:t>한 줄 요약: GitHub에서 요즘 뜨는 프로젝트들을 AI가 분석해서,
+결과가 별로면 다시 쓰고, 완성되면 메일이랑 GitHub에 자동으로 올려주는 프로그램</a:t>
+            </a:r>
+          </a:p>
+        </p:txBody>
+      </p:sp>
+      <p:sp>
+        <p:nvSpPr>
+          <p:cNvPr id="5" name="Rectangle 4"/>
           <p:cNvSpPr/>
           <p:nvPr/>
         </p:nvSpPr>
         <p:spPr>
           <a:xfrm>
-            <a:off x="274320" y="1005840"/>
-            <a:ext cx="4114800" cy="3474720"/>
+            <a:off x="182880" y="1737360"/>
+            <a:ext cx="1143000" cy="2286000"/>
+          </a:xfrm>
+          <a:prstGeom prst="rect">
+            <a:avLst/>
+          </a:prstGeom>
+          <a:solidFill>
+            <a:srgbClr val="161B22"/>
+          </a:solidFill>
+          <a:ln w="19050">
+            <a:solidFill>
+              <a:srgbClr val="58A6FF"/>
+            </a:solidFill>
+          </a:ln>
+        </p:spPr>
+        <p:style>
+          <a:lnRef idx="1">
+            <a:schemeClr val="accent1"/>
+          </a:lnRef>
+          <a:fillRef idx="3">
+            <a:schemeClr val="accent1"/>
+          </a:fillRef>
+          <a:effectRef idx="2">
+            <a:schemeClr val="accent1"/>
+          </a:effectRef>
+          <a:fontRef idx="minor">
+            <a:schemeClr val="lt1"/>
+          </a:fontRef>
+        </p:style>
+        <p:txBody>
+          <a:bodyPr rtlCol="0" anchor="ctr"/>
+          <a:lstStyle/>
+          <a:p>
+            <a:pPr algn="ctr"/>
+          </a:p>
+        </p:txBody>
+      </p:sp>
+      <p:sp>
+        <p:nvSpPr>
+          <p:cNvPr id="6" name="TextBox 5"/>
+          <p:cNvSpPr txBox="1"/>
+          <p:nvPr/>
+        </p:nvSpPr>
+        <p:spPr>
+          <a:xfrm>
+            <a:off x="292608" y="1828800"/>
+            <a:ext cx="923544" cy="2148840"/>
+          </a:xfrm>
+          <a:prstGeom prst="rect">
+            <a:avLst/>
+          </a:prstGeom>
+          <a:noFill/>
+        </p:spPr>
+        <p:txBody>
+          <a:bodyPr wrap="square">
+            <a:spAutoFit/>
+          </a:bodyPr>
+          <a:lstStyle/>
+          <a:p>
+            <a:r>
+              <a:rPr sz="1200">
+                <a:solidFill>
+                  <a:srgbClr val="FFFFFF"/>
+                </a:solidFill>
+              </a:rPr>
+              <a:t>수집
+GitHub에서
+트렌딩 레포
+가져오기</a:t>
+            </a:r>
+          </a:p>
+        </p:txBody>
+      </p:sp>
+      <p:sp>
+        <p:nvSpPr>
+          <p:cNvPr id="7" name="Rectangle 6"/>
+          <p:cNvSpPr/>
+          <p:nvPr/>
+        </p:nvSpPr>
+        <p:spPr>
+          <a:xfrm>
+            <a:off x="1435608" y="1737360"/>
+            <a:ext cx="1143000" cy="2286000"/>
+          </a:xfrm>
+          <a:prstGeom prst="rect">
+            <a:avLst/>
+          </a:prstGeom>
+          <a:solidFill>
+            <a:srgbClr val="161B22"/>
+          </a:solidFill>
+          <a:ln w="19050">
+            <a:solidFill>
+              <a:srgbClr val="D29E22"/>
+            </a:solidFill>
+          </a:ln>
+        </p:spPr>
+        <p:style>
+          <a:lnRef idx="1">
+            <a:schemeClr val="accent1"/>
+          </a:lnRef>
+          <a:fillRef idx="3">
+            <a:schemeClr val="accent1"/>
+          </a:fillRef>
+          <a:effectRef idx="2">
+            <a:schemeClr val="accent1"/>
+          </a:effectRef>
+          <a:fontRef idx="minor">
+            <a:schemeClr val="lt1"/>
+          </a:fontRef>
+        </p:style>
+        <p:txBody>
+          <a:bodyPr rtlCol="0" anchor="ctr"/>
+          <a:lstStyle/>
+          <a:p>
+            <a:pPr algn="ctr"/>
+          </a:p>
+        </p:txBody>
+      </p:sp>
+      <p:sp>
+        <p:nvSpPr>
+          <p:cNvPr id="8" name="TextBox 7"/>
+          <p:cNvSpPr txBox="1"/>
+          <p:nvPr/>
+        </p:nvSpPr>
+        <p:spPr>
+          <a:xfrm>
+            <a:off x="1545336" y="1828800"/>
+            <a:ext cx="923544" cy="2148840"/>
+          </a:xfrm>
+          <a:prstGeom prst="rect">
+            <a:avLst/>
+          </a:prstGeom>
+          <a:noFill/>
+        </p:spPr>
+        <p:txBody>
+          <a:bodyPr wrap="square">
+            <a:spAutoFit/>
+          </a:bodyPr>
+          <a:lstStyle/>
+          <a:p>
+            <a:r>
+              <a:rPr sz="1200">
+                <a:solidFill>
+                  <a:srgbClr val="FFFFFF"/>
+                </a:solidFill>
+              </a:rPr>
+              <a:t>검증
+데이터가
+충분한지
+확인</a:t>
+            </a:r>
+          </a:p>
+        </p:txBody>
+      </p:sp>
+      <p:sp>
+        <p:nvSpPr>
+          <p:cNvPr id="9" name="Rectangle 8"/>
+          <p:cNvSpPr/>
+          <p:nvPr/>
+        </p:nvSpPr>
+        <p:spPr>
+          <a:xfrm>
+            <a:off x="2688336" y="1737360"/>
+            <a:ext cx="1143000" cy="2286000"/>
+          </a:xfrm>
+          <a:prstGeom prst="rect">
+            <a:avLst/>
+          </a:prstGeom>
+          <a:solidFill>
+            <a:srgbClr val="161B22"/>
+          </a:solidFill>
+          <a:ln w="19050">
+            <a:solidFill>
+              <a:srgbClr val="58A6FF"/>
+            </a:solidFill>
+          </a:ln>
+        </p:spPr>
+        <p:style>
+          <a:lnRef idx="1">
+            <a:schemeClr val="accent1"/>
+          </a:lnRef>
+          <a:fillRef idx="3">
+            <a:schemeClr val="accent1"/>
+          </a:fillRef>
+          <a:effectRef idx="2">
+            <a:schemeClr val="accent1"/>
+          </a:effectRef>
+          <a:fontRef idx="minor">
+            <a:schemeClr val="lt1"/>
+          </a:fontRef>
+        </p:style>
+        <p:txBody>
+          <a:bodyPr rtlCol="0" anchor="ctr"/>
+          <a:lstStyle/>
+          <a:p>
+            <a:pPr algn="ctr"/>
+          </a:p>
+        </p:txBody>
+      </p:sp>
+      <p:sp>
+        <p:nvSpPr>
+          <p:cNvPr id="10" name="TextBox 9"/>
+          <p:cNvSpPr txBox="1"/>
+          <p:nvPr/>
+        </p:nvSpPr>
+        <p:spPr>
+          <a:xfrm>
+            <a:off x="2798064" y="1828800"/>
+            <a:ext cx="923544" cy="2148840"/>
+          </a:xfrm>
+          <a:prstGeom prst="rect">
+            <a:avLst/>
+          </a:prstGeom>
+          <a:noFill/>
+        </p:spPr>
+        <p:txBody>
+          <a:bodyPr wrap="square">
+            <a:spAutoFit/>
+          </a:bodyPr>
+          <a:lstStyle/>
+          <a:p>
+            <a:r>
+              <a:rPr sz="1200">
+                <a:solidFill>
+                  <a:srgbClr val="FFFFFF"/>
+                </a:solidFill>
+              </a:rPr>
+              <a:t>생성
+AI가
+보고서
+작성</a:t>
+            </a:r>
+          </a:p>
+        </p:txBody>
+      </p:sp>
+      <p:sp>
+        <p:nvSpPr>
+          <p:cNvPr id="11" name="Rectangle 10"/>
+          <p:cNvSpPr/>
+          <p:nvPr/>
+        </p:nvSpPr>
+        <p:spPr>
+          <a:xfrm>
+            <a:off x="3941064" y="1737360"/>
+            <a:ext cx="1143000" cy="2286000"/>
+          </a:xfrm>
+          <a:prstGeom prst="rect">
+            <a:avLst/>
+          </a:prstGeom>
+          <a:solidFill>
+            <a:srgbClr val="161B22"/>
+          </a:solidFill>
+          <a:ln w="19050">
+            <a:solidFill>
+              <a:srgbClr val="D29E22"/>
+            </a:solidFill>
+          </a:ln>
+        </p:spPr>
+        <p:style>
+          <a:lnRef idx="1">
+            <a:schemeClr val="accent1"/>
+          </a:lnRef>
+          <a:fillRef idx="3">
+            <a:schemeClr val="accent1"/>
+          </a:fillRef>
+          <a:effectRef idx="2">
+            <a:schemeClr val="accent1"/>
+          </a:effectRef>
+          <a:fontRef idx="minor">
+            <a:schemeClr val="lt1"/>
+          </a:fontRef>
+        </p:style>
+        <p:txBody>
+          <a:bodyPr rtlCol="0" anchor="ctr"/>
+          <a:lstStyle/>
+          <a:p>
+            <a:pPr algn="ctr"/>
+          </a:p>
+        </p:txBody>
+      </p:sp>
+      <p:sp>
+        <p:nvSpPr>
+          <p:cNvPr id="12" name="TextBox 11"/>
+          <p:cNvSpPr txBox="1"/>
+          <p:nvPr/>
+        </p:nvSpPr>
+        <p:spPr>
+          <a:xfrm>
+            <a:off x="4050792" y="1828800"/>
+            <a:ext cx="923544" cy="2148840"/>
+          </a:xfrm>
+          <a:prstGeom prst="rect">
+            <a:avLst/>
+          </a:prstGeom>
+          <a:noFill/>
+        </p:spPr>
+        <p:txBody>
+          <a:bodyPr wrap="square">
+            <a:spAutoFit/>
+          </a:bodyPr>
+          <a:lstStyle/>
+          <a:p>
+            <a:r>
+              <a:rPr sz="1200">
+                <a:solidFill>
+                  <a:srgbClr val="FFFFFF"/>
+                </a:solidFill>
+              </a:rPr>
+              <a:t>검사
+보고서
+품질
+채점</a:t>
+            </a:r>
+          </a:p>
+        </p:txBody>
+      </p:sp>
+      <p:sp>
+        <p:nvSpPr>
+          <p:cNvPr id="13" name="Rectangle 12"/>
+          <p:cNvSpPr/>
+          <p:nvPr/>
+        </p:nvSpPr>
+        <p:spPr>
+          <a:xfrm>
+            <a:off x="5193792" y="1737360"/>
+            <a:ext cx="1143000" cy="2286000"/>
+          </a:xfrm>
+          <a:prstGeom prst="rect">
+            <a:avLst/>
+          </a:prstGeom>
+          <a:solidFill>
+            <a:srgbClr val="161B22"/>
+          </a:solidFill>
+          <a:ln w="19050">
+            <a:solidFill>
+              <a:srgbClr val="58A6FF"/>
+            </a:solidFill>
+          </a:ln>
+        </p:spPr>
+        <p:style>
+          <a:lnRef idx="1">
+            <a:schemeClr val="accent1"/>
+          </a:lnRef>
+          <a:fillRef idx="3">
+            <a:schemeClr val="accent1"/>
+          </a:fillRef>
+          <a:effectRef idx="2">
+            <a:schemeClr val="accent1"/>
+          </a:effectRef>
+          <a:fontRef idx="minor">
+            <a:schemeClr val="lt1"/>
+          </a:fontRef>
+        </p:style>
+        <p:txBody>
+          <a:bodyPr rtlCol="0" anchor="ctr"/>
+          <a:lstStyle/>
+          <a:p>
+            <a:pPr algn="ctr"/>
+          </a:p>
+        </p:txBody>
+      </p:sp>
+      <p:sp>
+        <p:nvSpPr>
+          <p:cNvPr id="14" name="TextBox 13"/>
+          <p:cNvSpPr txBox="1"/>
+          <p:nvPr/>
+        </p:nvSpPr>
+        <p:spPr>
+          <a:xfrm>
+            <a:off x="5303520" y="1828800"/>
+            <a:ext cx="923544" cy="2148840"/>
+          </a:xfrm>
+          <a:prstGeom prst="rect">
+            <a:avLst/>
+          </a:prstGeom>
+          <a:noFill/>
+        </p:spPr>
+        <p:txBody>
+          <a:bodyPr wrap="square">
+            <a:spAutoFit/>
+          </a:bodyPr>
+          <a:lstStyle/>
+          <a:p>
+            <a:r>
+              <a:rPr sz="1200">
+                <a:solidFill>
+                  <a:srgbClr val="FFFFFF"/>
+                </a:solidFill>
+              </a:rPr>
+              <a:t>비교
+저번
+분석이랑
+비교</a:t>
+            </a:r>
+          </a:p>
+        </p:txBody>
+      </p:sp>
+      <p:sp>
+        <p:nvSpPr>
+          <p:cNvPr id="15" name="Rectangle 14"/>
+          <p:cNvSpPr/>
+          <p:nvPr/>
+        </p:nvSpPr>
+        <p:spPr>
+          <a:xfrm>
+            <a:off x="6446520" y="1737360"/>
+            <a:ext cx="1143000" cy="2286000"/>
+          </a:xfrm>
+          <a:prstGeom prst="rect">
+            <a:avLst/>
+          </a:prstGeom>
+          <a:solidFill>
+            <a:srgbClr val="161B22"/>
+          </a:solidFill>
+          <a:ln w="19050">
+            <a:solidFill>
+              <a:srgbClr val="3FB950"/>
+            </a:solidFill>
+          </a:ln>
+        </p:spPr>
+        <p:style>
+          <a:lnRef idx="1">
+            <a:schemeClr val="accent1"/>
+          </a:lnRef>
+          <a:fillRef idx="3">
+            <a:schemeClr val="accent1"/>
+          </a:fillRef>
+          <a:effectRef idx="2">
+            <a:schemeClr val="accent1"/>
+          </a:effectRef>
+          <a:fontRef idx="minor">
+            <a:schemeClr val="lt1"/>
+          </a:fontRef>
+        </p:style>
+        <p:txBody>
+          <a:bodyPr rtlCol="0" anchor="ctr"/>
+          <a:lstStyle/>
+          <a:p>
+            <a:pPr algn="ctr"/>
+          </a:p>
+        </p:txBody>
+      </p:sp>
+      <p:sp>
+        <p:nvSpPr>
+          <p:cNvPr id="16" name="TextBox 15"/>
+          <p:cNvSpPr txBox="1"/>
+          <p:nvPr/>
+        </p:nvSpPr>
+        <p:spPr>
+          <a:xfrm>
+            <a:off x="6556248" y="1828800"/>
+            <a:ext cx="923544" cy="2148840"/>
+          </a:xfrm>
+          <a:prstGeom prst="rect">
+            <a:avLst/>
+          </a:prstGeom>
+          <a:noFill/>
+        </p:spPr>
+        <p:txBody>
+          <a:bodyPr wrap="square">
+            <a:spAutoFit/>
+          </a:bodyPr>
+          <a:lstStyle/>
+          <a:p>
+            <a:r>
+              <a:rPr sz="1200">
+                <a:solidFill>
+                  <a:srgbClr val="FFFFFF"/>
+                </a:solidFill>
+              </a:rPr>
+              <a:t>발송
+메일+
+GitHub
+업로드</a:t>
+            </a:r>
+          </a:p>
+        </p:txBody>
+      </p:sp>
+      <p:sp>
+        <p:nvSpPr>
+          <p:cNvPr id="17" name="Rectangle 16"/>
+          <p:cNvSpPr/>
+          <p:nvPr/>
+        </p:nvSpPr>
+        <p:spPr>
+          <a:xfrm>
+            <a:off x="7699248" y="1737360"/>
+            <a:ext cx="1143000" cy="2286000"/>
           </a:xfrm>
           <a:prstGeom prst="rect">
             <a:avLst/>
@@ -3478,14 +4223,14 @@
       </p:sp>
       <p:sp>
         <p:nvSpPr>
-          <p:cNvPr id="5" name="TextBox 4"/>
+          <p:cNvPr id="18" name="TextBox 17"/>
           <p:cNvSpPr txBox="1"/>
           <p:nvPr/>
         </p:nvSpPr>
         <p:spPr>
           <a:xfrm>
-            <a:off x="365760" y="1078992"/>
-            <a:ext cx="3931920" cy="3383280"/>
+            <a:off x="7808976" y="1828800"/>
+            <a:ext cx="923544" cy="2148840"/>
           </a:xfrm>
           <a:prstGeom prst="rect">
             <a:avLst/>
@@ -3499,75 +4244,29 @@
           <a:lstStyle/>
           <a:p>
             <a:r>
-              <a:rPr sz="1300">
+              <a:rPr sz="1200">
                 <a:solidFill>
                   <a:srgbClr val="FFFFFF"/>
                 </a:solidFill>
               </a:rPr>
-              <a:t>9주차
-collect → validate → analyze → compare → report
-• analyze 노드 1번 실행
-• 결과가 나쁘더라도 그냥 저장
-• 품질 검토 없음</a:t>
-            </a:r>
-          </a:p>
-        </p:txBody>
-      </p:sp>
-      <p:sp>
-        <p:nvSpPr>
-          <p:cNvPr id="6" name="Rectangle 5"/>
-          <p:cNvSpPr/>
-          <p:nvPr/>
-        </p:nvSpPr>
-        <p:spPr>
-          <a:xfrm>
-            <a:off x="4754880" y="1005840"/>
-            <a:ext cx="4114800" cy="3474720"/>
-          </a:xfrm>
-          <a:prstGeom prst="rect">
-            <a:avLst/>
-          </a:prstGeom>
-          <a:solidFill>
-            <a:srgbClr val="161B22"/>
-          </a:solidFill>
-          <a:ln w="19050">
-            <a:solidFill>
-              <a:srgbClr val="58A6FF"/>
-            </a:solidFill>
-          </a:ln>
-        </p:spPr>
-        <p:style>
-          <a:lnRef idx="1">
-            <a:schemeClr val="accent1"/>
-          </a:lnRef>
-          <a:fillRef idx="3">
-            <a:schemeClr val="accent1"/>
-          </a:fillRef>
-          <a:effectRef idx="2">
-            <a:schemeClr val="accent1"/>
-          </a:effectRef>
-          <a:fontRef idx="minor">
-            <a:schemeClr val="lt1"/>
-          </a:fontRef>
-        </p:style>
-        <p:txBody>
-          <a:bodyPr rtlCol="0" anchor="ctr"/>
-          <a:lstStyle/>
-          <a:p>
-            <a:pPr algn="ctr"/>
-          </a:p>
-        </p:txBody>
-      </p:sp>
-      <p:sp>
-        <p:nvSpPr>
-          <p:cNvPr id="7" name="TextBox 6"/>
+              <a:t>저장
+결과
+JSON
+저장</a:t>
+            </a:r>
+          </a:p>
+        </p:txBody>
+      </p:sp>
+      <p:sp>
+        <p:nvSpPr>
+          <p:cNvPr id="19" name="TextBox 18"/>
           <p:cNvSpPr txBox="1"/>
           <p:nvPr/>
         </p:nvSpPr>
         <p:spPr>
           <a:xfrm>
-            <a:off x="4846320" y="1078992"/>
-            <a:ext cx="3931920" cy="3383280"/>
+            <a:off x="457200" y="4297680"/>
+            <a:ext cx="8229600" cy="457200"/>
           </a:xfrm>
           <a:prstGeom prst="rect">
             <a:avLst/>
@@ -3581,50 +4280,12 @@
           <a:lstStyle/>
           <a:p>
             <a:r>
-              <a:rPr sz="1300">
-                <a:solidFill>
-                  <a:srgbClr val="FFFFFF"/>
+              <a:rPr sz="1300" b="0">
+                <a:solidFill>
+                  <a:srgbClr val="3FB950"/>
                 </a:solidFill>
               </a:rPr>
-              <a:t>10주차
-collect → validate → generate → reflect
-→ compare → notify → report
-• reflect 노드: 품질 자동 채점 (0~100점)
-• 70점 미만 → 피드백 반영해서 재생성
-• notify 노드: Gmail + GitHub README 자동 발송</a:t>
-            </a:r>
-          </a:p>
-        </p:txBody>
-      </p:sp>
-      <p:sp>
-        <p:nvSpPr>
-          <p:cNvPr id="8" name="TextBox 7"/>
-          <p:cNvSpPr txBox="1"/>
-          <p:nvPr/>
-        </p:nvSpPr>
-        <p:spPr>
-          <a:xfrm>
-            <a:off x="4297680" y="2377440"/>
-            <a:ext cx="457200" cy="457200"/>
-          </a:xfrm>
-          <a:prstGeom prst="rect">
-            <a:avLst/>
-          </a:prstGeom>
-          <a:noFill/>
-        </p:spPr>
-        <p:txBody>
-          <a:bodyPr wrap="square">
-            <a:spAutoFit/>
-          </a:bodyPr>
-          <a:lstStyle/>
-          <a:p>
-            <a:r>
-              <a:rPr sz="2400" b="1">
-                <a:solidFill>
-                  <a:srgbClr val="58A6FF"/>
-                </a:solidFill>
-              </a:rPr>
-              <a:t>→</a:t>
+              <a:t>9주차와 차이: '검사' 노드 추가 → 별로면 '생성'으로 되돌아감 (최대 3회)</a:t>
             </a:r>
           </a:p>
         </p:txBody>
@@ -3718,54 +4379,21 @@
                   <a:srgbClr val="58A6FF"/>
                 </a:solidFill>
               </a:rPr>
-              <a:t>Self-Correction이란?</a:t>
-            </a:r>
-          </a:p>
-        </p:txBody>
-      </p:sp>
-      <p:sp>
-        <p:nvSpPr>
-          <p:cNvPr id="4" name="TextBox 3"/>
-          <p:cNvSpPr txBox="1"/>
-          <p:nvPr/>
-        </p:nvSpPr>
-        <p:spPr>
-          <a:xfrm>
-            <a:off x="457200" y="914400"/>
-            <a:ext cx="8229600" cy="457200"/>
-          </a:xfrm>
-          <a:prstGeom prst="rect">
-            <a:avLst/>
-          </a:prstGeom>
-          <a:noFill/>
-        </p:spPr>
-        <p:txBody>
-          <a:bodyPr wrap="square">
-            <a:spAutoFit/>
-          </a:bodyPr>
-          <a:lstStyle/>
-          <a:p>
-            <a:r>
-              <a:rPr sz="1600" b="0">
-                <a:solidFill>
-                  <a:srgbClr val="FFFFFF"/>
-                </a:solidFill>
-              </a:rPr>
-              <a:t>AI가 자기 결과를 스스로 검토하고, 기준에 미달하면 다시 생성하는 루프</a:t>
-            </a:r>
-          </a:p>
-        </p:txBody>
-      </p:sp>
-      <p:sp>
-        <p:nvSpPr>
-          <p:cNvPr id="5" name="Rectangle 4"/>
+              <a:t>트렌드를 어떻게 수집하나?</a:t>
+            </a:r>
+          </a:p>
+        </p:txBody>
+      </p:sp>
+      <p:sp>
+        <p:nvSpPr>
+          <p:cNvPr id="4" name="Rectangle 3"/>
           <p:cNvSpPr/>
           <p:nvPr/>
         </p:nvSpPr>
         <p:spPr>
           <a:xfrm>
-            <a:off x="274320" y="1554480"/>
-            <a:ext cx="2011680" cy="2560320"/>
+            <a:off x="365760" y="1005840"/>
+            <a:ext cx="4023360" cy="2926080"/>
           </a:xfrm>
           <a:prstGeom prst="rect">
             <a:avLst/>
@@ -3803,14 +4431,14 @@
       </p:sp>
       <p:sp>
         <p:nvSpPr>
-          <p:cNvPr id="6" name="TextBox 5"/>
+          <p:cNvPr id="5" name="TextBox 4"/>
           <p:cNvSpPr txBox="1"/>
           <p:nvPr/>
         </p:nvSpPr>
         <p:spPr>
           <a:xfrm>
-            <a:off x="365760" y="1627632"/>
-            <a:ext cx="1828800" cy="2468880"/>
+            <a:off x="475488" y="1097280"/>
+            <a:ext cx="3803904" cy="2788920"/>
           </a:xfrm>
           <a:prstGeom prst="rect">
             <a:avLst/>
@@ -3824,187 +4452,30 @@
           <a:lstStyle/>
           <a:p>
             <a:r>
-              <a:rPr sz="1300">
+              <a:rPr sz="1400">
                 <a:solidFill>
                   <a:srgbClr val="FFFFFF"/>
                 </a:solidFill>
               </a:rPr>
-              <a:t>🤖 Generate
-AI가 트렌드 분석 결과를 처음 생성</a:t>
-            </a:r>
-          </a:p>
-        </p:txBody>
-      </p:sp>
-      <p:sp>
-        <p:nvSpPr>
-          <p:cNvPr id="7" name="Rectangle 6"/>
+              <a:t>GitHub에 공식 트렌딩 API가 없다
+그래서 이렇게 우회함:
+"최근 7일 안에 만들어진 레포 중에
+ 스타(★)를 10개 이상 받은 것들을
+ 스타 많은 순서로 정렬"</a:t>
+            </a:r>
+          </a:p>
+        </p:txBody>
+      </p:sp>
+      <p:sp>
+        <p:nvSpPr>
+          <p:cNvPr id="6" name="Rectangle 5"/>
           <p:cNvSpPr/>
           <p:nvPr/>
         </p:nvSpPr>
         <p:spPr>
           <a:xfrm>
-            <a:off x="2423160" y="1554480"/>
-            <a:ext cx="2011680" cy="2560320"/>
-          </a:xfrm>
-          <a:prstGeom prst="rect">
-            <a:avLst/>
-          </a:prstGeom>
-          <a:solidFill>
-            <a:srgbClr val="161B22"/>
-          </a:solidFill>
-          <a:ln w="19050">
-            <a:solidFill>
-              <a:srgbClr val="D29E22"/>
-            </a:solidFill>
-          </a:ln>
-        </p:spPr>
-        <p:style>
-          <a:lnRef idx="1">
-            <a:schemeClr val="accent1"/>
-          </a:lnRef>
-          <a:fillRef idx="3">
-            <a:schemeClr val="accent1"/>
-          </a:fillRef>
-          <a:effectRef idx="2">
-            <a:schemeClr val="accent1"/>
-          </a:effectRef>
-          <a:fontRef idx="minor">
-            <a:schemeClr val="lt1"/>
-          </a:fontRef>
-        </p:style>
-        <p:txBody>
-          <a:bodyPr rtlCol="0" anchor="ctr"/>
-          <a:lstStyle/>
-          <a:p>
-            <a:pPr algn="ctr"/>
-          </a:p>
-        </p:txBody>
-      </p:sp>
-      <p:sp>
-        <p:nvSpPr>
-          <p:cNvPr id="8" name="TextBox 7"/>
-          <p:cNvSpPr txBox="1"/>
-          <p:nvPr/>
-        </p:nvSpPr>
-        <p:spPr>
-          <a:xfrm>
-            <a:off x="2514600" y="1627632"/>
-            <a:ext cx="1828800" cy="2468880"/>
-          </a:xfrm>
-          <a:prstGeom prst="rect">
-            <a:avLst/>
-          </a:prstGeom>
-          <a:noFill/>
-        </p:spPr>
-        <p:txBody>
-          <a:bodyPr wrap="square">
-            <a:spAutoFit/>
-          </a:bodyPr>
-          <a:lstStyle/>
-          <a:p>
-            <a:r>
-              <a:rPr sz="1300">
-                <a:solidFill>
-                  <a:srgbClr val="FFFFFF"/>
-                </a:solidFill>
-              </a:rPr>
-              <a:t>🔍 Reflect
-기준표로 자동 채점
-(길이·키워드·레포 이름·인사이트·방향성)</a:t>
-            </a:r>
-          </a:p>
-        </p:txBody>
-      </p:sp>
-      <p:sp>
-        <p:nvSpPr>
-          <p:cNvPr id="9" name="Rectangle 8"/>
-          <p:cNvSpPr/>
-          <p:nvPr/>
-        </p:nvSpPr>
-        <p:spPr>
-          <a:xfrm>
-            <a:off x="4572000" y="1554480"/>
-            <a:ext cx="2011680" cy="2560320"/>
-          </a:xfrm>
-          <a:prstGeom prst="rect">
-            <a:avLst/>
-          </a:prstGeom>
-          <a:solidFill>
-            <a:srgbClr val="161B22"/>
-          </a:solidFill>
-          <a:ln w="19050">
-            <a:solidFill>
-              <a:srgbClr val="F85149"/>
-            </a:solidFill>
-          </a:ln>
-        </p:spPr>
-        <p:style>
-          <a:lnRef idx="1">
-            <a:schemeClr val="accent1"/>
-          </a:lnRef>
-          <a:fillRef idx="3">
-            <a:schemeClr val="accent1"/>
-          </a:fillRef>
-          <a:effectRef idx="2">
-            <a:schemeClr val="accent1"/>
-          </a:effectRef>
-          <a:fontRef idx="minor">
-            <a:schemeClr val="lt1"/>
-          </a:fontRef>
-        </p:style>
-        <p:txBody>
-          <a:bodyPr rtlCol="0" anchor="ctr"/>
-          <a:lstStyle/>
-          <a:p>
-            <a:pPr algn="ctr"/>
-          </a:p>
-        </p:txBody>
-      </p:sp>
-      <p:sp>
-        <p:nvSpPr>
-          <p:cNvPr id="10" name="TextBox 9"/>
-          <p:cNvSpPr txBox="1"/>
-          <p:nvPr/>
-        </p:nvSpPr>
-        <p:spPr>
-          <a:xfrm>
-            <a:off x="4663440" y="1627632"/>
-            <a:ext cx="1828800" cy="2468880"/>
-          </a:xfrm>
-          <a:prstGeom prst="rect">
-            <a:avLst/>
-          </a:prstGeom>
-          <a:noFill/>
-        </p:spPr>
-        <p:txBody>
-          <a:bodyPr wrap="square">
-            <a:spAutoFit/>
-          </a:bodyPr>
-          <a:lstStyle/>
-          <a:p>
-            <a:r>
-              <a:rPr sz="1300">
-                <a:solidFill>
-                  <a:srgbClr val="FFFFFF"/>
-                </a:solidFill>
-              </a:rPr>
-              <a:t>❌ Fail
-70점 미만이면
-피드백을 붙여서 다시 Generate로</a:t>
-            </a:r>
-          </a:p>
-        </p:txBody>
-      </p:sp>
-      <p:sp>
-        <p:nvSpPr>
-          <p:cNvPr id="11" name="Rectangle 10"/>
-          <p:cNvSpPr/>
-          <p:nvPr/>
-        </p:nvSpPr>
-        <p:spPr>
-          <a:xfrm>
-            <a:off x="6720840" y="1554480"/>
-            <a:ext cx="2011680" cy="2560320"/>
+            <a:off x="4663440" y="1005840"/>
+            <a:ext cx="4023360" cy="2926080"/>
           </a:xfrm>
           <a:prstGeom prst="rect">
             <a:avLst/>
@@ -4042,14 +4513,14 @@
       </p:sp>
       <p:sp>
         <p:nvSpPr>
-          <p:cNvPr id="12" name="TextBox 11"/>
+          <p:cNvPr id="7" name="TextBox 6"/>
           <p:cNvSpPr txBox="1"/>
           <p:nvPr/>
         </p:nvSpPr>
         <p:spPr>
           <a:xfrm>
-            <a:off x="6812280" y="1627632"/>
-            <a:ext cx="1828800" cy="2468880"/>
+            <a:off x="4773168" y="1097280"/>
+            <a:ext cx="3803904" cy="2788920"/>
           </a:xfrm>
           <a:prstGeom prst="rect">
             <a:avLst/>
@@ -4063,27 +4534,31 @@
           <a:lstStyle/>
           <a:p>
             <a:r>
-              <a:rPr sz="1300">
+              <a:rPr sz="1400">
                 <a:solidFill>
                   <a:srgbClr val="FFFFFF"/>
                 </a:solidFill>
               </a:rPr>
-              <a:t>✅ Pass
-70점 이상이면
-다음 단계(compare)로 진행</a:t>
-            </a:r>
-          </a:p>
-        </p:txBody>
-      </p:sp>
-      <p:sp>
-        <p:nvSpPr>
-          <p:cNvPr id="13" name="TextBox 12"/>
+              <a:t>기간별 기준
+오늘    → 오늘 하루 안에 만들어진 것
+이번 주 → 7일 안에 만들어진 것
+이번 달 → 30일 안에 만들어진 것
+스타 = 관심 표시 (좋아요 같은 것)
+갓 만들어졌는데 스타 많음
+= 요즘 뜨는 것</a:t>
+            </a:r>
+          </a:p>
+        </p:txBody>
+      </p:sp>
+      <p:sp>
+        <p:nvSpPr>
+          <p:cNvPr id="8" name="TextBox 7"/>
           <p:cNvSpPr txBox="1"/>
           <p:nvPr/>
         </p:nvSpPr>
         <p:spPr>
           <a:xfrm>
-            <a:off x="457200" y="4297680"/>
+            <a:off x="457200" y="4206240"/>
             <a:ext cx="8229600" cy="457200"/>
           </a:xfrm>
           <a:prstGeom prst="rect">
@@ -4103,7 +4578,7 @@
                   <a:srgbClr val="8B949E"/>
                 </a:solidFill>
               </a:rPr>
-              <a:t>핵심: AI 결과를 믿지 말고 검증하라. 기준을 코드로 명확히 정의하면 자동으로 품질이 올라간다.</a:t>
+              <a:t>트렌드 데이터는 GitHub API가 수집 → 이건 객관적인 숫자라 틀릴 수 없음</a:t>
             </a:r>
           </a:p>
         </p:txBody>
@@ -4197,7 +4672,7 @@
                   <a:srgbClr val="58A6FF"/>
                 </a:solidFill>
               </a:rPr>
-              <a:t>LangGraph 흐름 설계</a:t>
+              <a:t>왜 Self-Correction이 필요한가?</a:t>
             </a:r>
           </a:p>
         </p:txBody>
@@ -4211,7 +4686,7 @@
         <p:spPr>
           <a:xfrm>
             <a:off x="365760" y="1005840"/>
-            <a:ext cx="8412480" cy="2011680"/>
+            <a:ext cx="4023360" cy="3200400"/>
           </a:xfrm>
           <a:prstGeom prst="rect">
             <a:avLst/>
@@ -4221,7 +4696,7 @@
           </a:solidFill>
           <a:ln w="19050">
             <a:solidFill>
-              <a:srgbClr val="58A6FF"/>
+              <a:srgbClr val="F85149"/>
             </a:solidFill>
           </a:ln>
         </p:spPr>
@@ -4255,8 +4730,8 @@
         </p:nvSpPr>
         <p:spPr>
           <a:xfrm>
-            <a:off x="457200" y="1078992"/>
-            <a:ext cx="8229600" cy="1920240"/>
+            <a:off x="475488" y="1097280"/>
+            <a:ext cx="3803904" cy="3063240"/>
           </a:xfrm>
           <a:prstGeom prst="rect">
             <a:avLst/>
@@ -4275,12 +4750,11 @@
                   <a:srgbClr val="FFFFFF"/>
                 </a:solidFill>
               </a:rPr>
-              <a:t>collect  →  validate  →  generate  →  reflect
-              ↑↓                        ↑↓
-         (데이터 부족)           (점수 70 미만)
-          재수집 최대 3회         재생성 최대 3회
-                                        ↓ 점수 70 이상
-                               compare  →  notify  →  report  →  END</a:t>
+              <a:t>AI한테 "트렌드 분석해줘" 라고 하면
+가끔 이런 답이 나옴:
+"요즘 AI 관련 프로젝트가 많습니다."
+→ 너무 짧고 구체적인 내용이 없음
+→ 근데 AI는 이게 별로인 줄 모름</a:t>
             </a:r>
           </a:p>
         </p:txBody>
@@ -4293,88 +4767,8 @@
         </p:nvSpPr>
         <p:spPr>
           <a:xfrm>
-            <a:off x="182880" y="3200400"/>
-            <a:ext cx="1143000" cy="1645920"/>
-          </a:xfrm>
-          <a:prstGeom prst="rect">
-            <a:avLst/>
-          </a:prstGeom>
-          <a:solidFill>
-            <a:srgbClr val="161B22"/>
-          </a:solidFill>
-          <a:ln w="19050">
-            <a:solidFill>
-              <a:srgbClr val="58A6FF"/>
-            </a:solidFill>
-          </a:ln>
-        </p:spPr>
-        <p:style>
-          <a:lnRef idx="1">
-            <a:schemeClr val="accent1"/>
-          </a:lnRef>
-          <a:fillRef idx="3">
-            <a:schemeClr val="accent1"/>
-          </a:fillRef>
-          <a:effectRef idx="2">
-            <a:schemeClr val="accent1"/>
-          </a:effectRef>
-          <a:fontRef idx="minor">
-            <a:schemeClr val="lt1"/>
-          </a:fontRef>
-        </p:style>
-        <p:txBody>
-          <a:bodyPr rtlCol="0" anchor="ctr"/>
-          <a:lstStyle/>
-          <a:p>
-            <a:pPr algn="ctr"/>
-          </a:p>
-        </p:txBody>
-      </p:sp>
-      <p:sp>
-        <p:nvSpPr>
-          <p:cNvPr id="7" name="TextBox 6"/>
-          <p:cNvSpPr txBox="1"/>
-          <p:nvPr/>
-        </p:nvSpPr>
-        <p:spPr>
-          <a:xfrm>
-            <a:off x="274320" y="3273552"/>
-            <a:ext cx="960120" cy="1554480"/>
-          </a:xfrm>
-          <a:prstGeom prst="rect">
-            <a:avLst/>
-          </a:prstGeom>
-          <a:noFill/>
-        </p:spPr>
-        <p:txBody>
-          <a:bodyPr wrap="square">
-            <a:spAutoFit/>
-          </a:bodyPr>
-          <a:lstStyle/>
-          <a:p>
-            <a:r>
-              <a:rPr sz="1100">
-                <a:solidFill>
-                  <a:srgbClr val="FFFFFF"/>
-                </a:solidFill>
-              </a:rPr>
-              <a:t>collect
-GitHub API
-데이터 수집</a:t>
-            </a:r>
-          </a:p>
-        </p:txBody>
-      </p:sp>
-      <p:sp>
-        <p:nvSpPr>
-          <p:cNvPr id="8" name="Rectangle 7"/>
-          <p:cNvSpPr/>
-          <p:nvPr/>
-        </p:nvSpPr>
-        <p:spPr>
-          <a:xfrm>
-            <a:off x="1435608" y="3200400"/>
-            <a:ext cx="1143000" cy="1645920"/>
+            <a:off x="4663440" y="1005840"/>
+            <a:ext cx="4023360" cy="3200400"/>
           </a:xfrm>
           <a:prstGeom prst="rect">
             <a:avLst/>
@@ -4412,14 +4806,14 @@
       </p:sp>
       <p:sp>
         <p:nvSpPr>
-          <p:cNvPr id="9" name="TextBox 8"/>
+          <p:cNvPr id="7" name="TextBox 6"/>
           <p:cNvSpPr txBox="1"/>
           <p:nvPr/>
         </p:nvSpPr>
         <p:spPr>
           <a:xfrm>
-            <a:off x="1527048" y="3273552"/>
-            <a:ext cx="960120" cy="1554480"/>
+            <a:off x="4773168" y="1097280"/>
+            <a:ext cx="3803904" cy="3063240"/>
           </a:xfrm>
           <a:prstGeom prst="rect">
             <a:avLst/>
@@ -4433,413 +4827,19 @@
           <a:lstStyle/>
           <a:p>
             <a:r>
-              <a:rPr sz="1100">
+              <a:rPr sz="1400">
                 <a:solidFill>
                   <a:srgbClr val="FFFFFF"/>
                 </a:solidFill>
               </a:rPr>
-              <a:t>validate
-레포 5개 이상?
-부족 시 재수집</a:t>
-            </a:r>
-          </a:p>
-        </p:txBody>
-      </p:sp>
-      <p:sp>
-        <p:nvSpPr>
-          <p:cNvPr id="10" name="Rectangle 9"/>
-          <p:cNvSpPr/>
-          <p:nvPr/>
-        </p:nvSpPr>
-        <p:spPr>
-          <a:xfrm>
-            <a:off x="2688336" y="3200400"/>
-            <a:ext cx="1143000" cy="1645920"/>
-          </a:xfrm>
-          <a:prstGeom prst="rect">
-            <a:avLst/>
-          </a:prstGeom>
-          <a:solidFill>
-            <a:srgbClr val="161B22"/>
-          </a:solidFill>
-          <a:ln w="19050">
-            <a:solidFill>
-              <a:srgbClr val="58A6FF"/>
-            </a:solidFill>
-          </a:ln>
-        </p:spPr>
-        <p:style>
-          <a:lnRef idx="1">
-            <a:schemeClr val="accent1"/>
-          </a:lnRef>
-          <a:fillRef idx="3">
-            <a:schemeClr val="accent1"/>
-          </a:fillRef>
-          <a:effectRef idx="2">
-            <a:schemeClr val="accent1"/>
-          </a:effectRef>
-          <a:fontRef idx="minor">
-            <a:schemeClr val="lt1"/>
-          </a:fontRef>
-        </p:style>
-        <p:txBody>
-          <a:bodyPr rtlCol="0" anchor="ctr"/>
-          <a:lstStyle/>
-          <a:p>
-            <a:pPr algn="ctr"/>
-          </a:p>
-        </p:txBody>
-      </p:sp>
-      <p:sp>
-        <p:nvSpPr>
-          <p:cNvPr id="11" name="TextBox 10"/>
-          <p:cNvSpPr txBox="1"/>
-          <p:nvPr/>
-        </p:nvSpPr>
-        <p:spPr>
-          <a:xfrm>
-            <a:off x="2779776" y="3273552"/>
-            <a:ext cx="960120" cy="1554480"/>
-          </a:xfrm>
-          <a:prstGeom prst="rect">
-            <a:avLst/>
-          </a:prstGeom>
-          <a:noFill/>
-        </p:spPr>
-        <p:txBody>
-          <a:bodyPr wrap="square">
-            <a:spAutoFit/>
-          </a:bodyPr>
-          <a:lstStyle/>
-          <a:p>
-            <a:r>
-              <a:rPr sz="1100">
-                <a:solidFill>
-                  <a:srgbClr val="FFFFFF"/>
-                </a:solidFill>
-              </a:rPr>
-              <a:t>generate
-AI 분석 생성
-피드백 반영</a:t>
-            </a:r>
-          </a:p>
-        </p:txBody>
-      </p:sp>
-      <p:sp>
-        <p:nvSpPr>
-          <p:cNvPr id="12" name="Rectangle 11"/>
-          <p:cNvSpPr/>
-          <p:nvPr/>
-        </p:nvSpPr>
-        <p:spPr>
-          <a:xfrm>
-            <a:off x="3941064" y="3200400"/>
-            <a:ext cx="1143000" cy="1645920"/>
-          </a:xfrm>
-          <a:prstGeom prst="rect">
-            <a:avLst/>
-          </a:prstGeom>
-          <a:solidFill>
-            <a:srgbClr val="161B22"/>
-          </a:solidFill>
-          <a:ln w="19050">
-            <a:solidFill>
-              <a:srgbClr val="D29E22"/>
-            </a:solidFill>
-          </a:ln>
-        </p:spPr>
-        <p:style>
-          <a:lnRef idx="1">
-            <a:schemeClr val="accent1"/>
-          </a:lnRef>
-          <a:fillRef idx="3">
-            <a:schemeClr val="accent1"/>
-          </a:fillRef>
-          <a:effectRef idx="2">
-            <a:schemeClr val="accent1"/>
-          </a:effectRef>
-          <a:fontRef idx="minor">
-            <a:schemeClr val="lt1"/>
-          </a:fontRef>
-        </p:style>
-        <p:txBody>
-          <a:bodyPr rtlCol="0" anchor="ctr"/>
-          <a:lstStyle/>
-          <a:p>
-            <a:pPr algn="ctr"/>
-          </a:p>
-        </p:txBody>
-      </p:sp>
-      <p:sp>
-        <p:nvSpPr>
-          <p:cNvPr id="13" name="TextBox 12"/>
-          <p:cNvSpPr txBox="1"/>
-          <p:nvPr/>
-        </p:nvSpPr>
-        <p:spPr>
-          <a:xfrm>
-            <a:off x="4032504" y="3273552"/>
-            <a:ext cx="960120" cy="1554480"/>
-          </a:xfrm>
-          <a:prstGeom prst="rect">
-            <a:avLst/>
-          </a:prstGeom>
-          <a:noFill/>
-        </p:spPr>
-        <p:txBody>
-          <a:bodyPr wrap="square">
-            <a:spAutoFit/>
-          </a:bodyPr>
-          <a:lstStyle/>
-          <a:p>
-            <a:r>
-              <a:rPr sz="1100">
-                <a:solidFill>
-                  <a:srgbClr val="FFFFFF"/>
-                </a:solidFill>
-              </a:rPr>
-              <a:t>reflect
-품질 채점
-0~100점</a:t>
-            </a:r>
-          </a:p>
-        </p:txBody>
-      </p:sp>
-      <p:sp>
-        <p:nvSpPr>
-          <p:cNvPr id="14" name="Rectangle 13"/>
-          <p:cNvSpPr/>
-          <p:nvPr/>
-        </p:nvSpPr>
-        <p:spPr>
-          <a:xfrm>
-            <a:off x="5193792" y="3200400"/>
-            <a:ext cx="1143000" cy="1645920"/>
-          </a:xfrm>
-          <a:prstGeom prst="rect">
-            <a:avLst/>
-          </a:prstGeom>
-          <a:solidFill>
-            <a:srgbClr val="161B22"/>
-          </a:solidFill>
-          <a:ln w="19050">
-            <a:solidFill>
-              <a:srgbClr val="58A6FF"/>
-            </a:solidFill>
-          </a:ln>
-        </p:spPr>
-        <p:style>
-          <a:lnRef idx="1">
-            <a:schemeClr val="accent1"/>
-          </a:lnRef>
-          <a:fillRef idx="3">
-            <a:schemeClr val="accent1"/>
-          </a:fillRef>
-          <a:effectRef idx="2">
-            <a:schemeClr val="accent1"/>
-          </a:effectRef>
-          <a:fontRef idx="minor">
-            <a:schemeClr val="lt1"/>
-          </a:fontRef>
-        </p:style>
-        <p:txBody>
-          <a:bodyPr rtlCol="0" anchor="ctr"/>
-          <a:lstStyle/>
-          <a:p>
-            <a:pPr algn="ctr"/>
-          </a:p>
-        </p:txBody>
-      </p:sp>
-      <p:sp>
-        <p:nvSpPr>
-          <p:cNvPr id="15" name="TextBox 14"/>
-          <p:cNvSpPr txBox="1"/>
-          <p:nvPr/>
-        </p:nvSpPr>
-        <p:spPr>
-          <a:xfrm>
-            <a:off x="5285232" y="3273552"/>
-            <a:ext cx="960120" cy="1554480"/>
-          </a:xfrm>
-          <a:prstGeom prst="rect">
-            <a:avLst/>
-          </a:prstGeom>
-          <a:noFill/>
-        </p:spPr>
-        <p:txBody>
-          <a:bodyPr wrap="square">
-            <a:spAutoFit/>
-          </a:bodyPr>
-          <a:lstStyle/>
-          <a:p>
-            <a:r>
-              <a:rPr sz="1100">
-                <a:solidFill>
-                  <a:srgbClr val="FFFFFF"/>
-                </a:solidFill>
-              </a:rPr>
-              <a:t>compare
-이전 기록
-비교</a:t>
-            </a:r>
-          </a:p>
-        </p:txBody>
-      </p:sp>
-      <p:sp>
-        <p:nvSpPr>
-          <p:cNvPr id="16" name="Rectangle 15"/>
-          <p:cNvSpPr/>
-          <p:nvPr/>
-        </p:nvSpPr>
-        <p:spPr>
-          <a:xfrm>
-            <a:off x="6446520" y="3200400"/>
-            <a:ext cx="1143000" cy="1645920"/>
-          </a:xfrm>
-          <a:prstGeom prst="rect">
-            <a:avLst/>
-          </a:prstGeom>
-          <a:solidFill>
-            <a:srgbClr val="161B22"/>
-          </a:solidFill>
-          <a:ln w="19050">
-            <a:solidFill>
-              <a:srgbClr val="3FB950"/>
-            </a:solidFill>
-          </a:ln>
-        </p:spPr>
-        <p:style>
-          <a:lnRef idx="1">
-            <a:schemeClr val="accent1"/>
-          </a:lnRef>
-          <a:fillRef idx="3">
-            <a:schemeClr val="accent1"/>
-          </a:fillRef>
-          <a:effectRef idx="2">
-            <a:schemeClr val="accent1"/>
-          </a:effectRef>
-          <a:fontRef idx="minor">
-            <a:schemeClr val="lt1"/>
-          </a:fontRef>
-        </p:style>
-        <p:txBody>
-          <a:bodyPr rtlCol="0" anchor="ctr"/>
-          <a:lstStyle/>
-          <a:p>
-            <a:pPr algn="ctr"/>
-          </a:p>
-        </p:txBody>
-      </p:sp>
-      <p:sp>
-        <p:nvSpPr>
-          <p:cNvPr id="17" name="TextBox 16"/>
-          <p:cNvSpPr txBox="1"/>
-          <p:nvPr/>
-        </p:nvSpPr>
-        <p:spPr>
-          <a:xfrm>
-            <a:off x="6537960" y="3273552"/>
-            <a:ext cx="960120" cy="1554480"/>
-          </a:xfrm>
-          <a:prstGeom prst="rect">
-            <a:avLst/>
-          </a:prstGeom>
-          <a:noFill/>
-        </p:spPr>
-        <p:txBody>
-          <a:bodyPr wrap="square">
-            <a:spAutoFit/>
-          </a:bodyPr>
-          <a:lstStyle/>
-          <a:p>
-            <a:r>
-              <a:rPr sz="1100">
-                <a:solidFill>
-                  <a:srgbClr val="FFFFFF"/>
-                </a:solidFill>
-              </a:rPr>
-              <a:t>notify
-Gmail+
-README</a:t>
-            </a:r>
-          </a:p>
-        </p:txBody>
-      </p:sp>
-      <p:sp>
-        <p:nvSpPr>
-          <p:cNvPr id="18" name="Rectangle 17"/>
-          <p:cNvSpPr/>
-          <p:nvPr/>
-        </p:nvSpPr>
-        <p:spPr>
-          <a:xfrm>
-            <a:off x="7699248" y="3200400"/>
-            <a:ext cx="1143000" cy="1645920"/>
-          </a:xfrm>
-          <a:prstGeom prst="rect">
-            <a:avLst/>
-          </a:prstGeom>
-          <a:solidFill>
-            <a:srgbClr val="161B22"/>
-          </a:solidFill>
-          <a:ln w="19050">
-            <a:solidFill>
-              <a:srgbClr val="8B949E"/>
-            </a:solidFill>
-          </a:ln>
-        </p:spPr>
-        <p:style>
-          <a:lnRef idx="1">
-            <a:schemeClr val="accent1"/>
-          </a:lnRef>
-          <a:fillRef idx="3">
-            <a:schemeClr val="accent1"/>
-          </a:fillRef>
-          <a:effectRef idx="2">
-            <a:schemeClr val="accent1"/>
-          </a:effectRef>
-          <a:fontRef idx="minor">
-            <a:schemeClr val="lt1"/>
-          </a:fontRef>
-        </p:style>
-        <p:txBody>
-          <a:bodyPr rtlCol="0" anchor="ctr"/>
-          <a:lstStyle/>
-          <a:p>
-            <a:pPr algn="ctr"/>
-          </a:p>
-        </p:txBody>
-      </p:sp>
-      <p:sp>
-        <p:nvSpPr>
-          <p:cNvPr id="19" name="TextBox 18"/>
-          <p:cNvSpPr txBox="1"/>
-          <p:nvPr/>
-        </p:nvSpPr>
-        <p:spPr>
-          <a:xfrm>
-            <a:off x="7790688" y="3273552"/>
-            <a:ext cx="960120" cy="1554480"/>
-          </a:xfrm>
-          <a:prstGeom prst="rect">
-            <a:avLst/>
-          </a:prstGeom>
-          <a:noFill/>
-        </p:spPr>
-        <p:txBody>
-          <a:bodyPr wrap="square">
-            <a:spAutoFit/>
-          </a:bodyPr>
-          <a:lstStyle/>
-          <a:p>
-            <a:r>
-              <a:rPr sz="1100">
-                <a:solidFill>
-                  <a:srgbClr val="FFFFFF"/>
-                </a:solidFill>
-              </a:rPr>
-              <a:t>report
-JSON 저장</a:t>
+              <a:t>AI는 자기가 쓴 게
+별로인지 스스로 잘 모름
+그냥 물어보면
+항상 "잘 썼습니다" 라고 해버림
+그래서 사람이 직접
+기준을 코드로 정해놓고
+코드가 대신 검사해주는 것
+= Self-Correction</a:t>
             </a:r>
           </a:p>
         </p:txBody>
@@ -4933,21 +4933,296 @@
                   <a:srgbClr val="58A6FF"/>
                 </a:solidFill>
               </a:rPr>
-              <a:t>품질 검토 기준 — reflect 노드</a:t>
-            </a:r>
-          </a:p>
-        </p:txBody>
-      </p:sp>
-      <p:sp>
-        <p:nvSpPr>
-          <p:cNvPr id="4" name="Rectangle 3"/>
+              <a:t>Self-Correction 동작 과정</a:t>
+            </a:r>
+          </a:p>
+        </p:txBody>
+      </p:sp>
+      <p:sp>
+        <p:nvSpPr>
+          <p:cNvPr id="4" name="TextBox 3"/>
+          <p:cNvSpPr txBox="1"/>
+          <p:nvPr/>
+        </p:nvSpPr>
+        <p:spPr>
+          <a:xfrm>
+            <a:off x="457200" y="914400"/>
+            <a:ext cx="8229600" cy="457200"/>
+          </a:xfrm>
+          <a:prstGeom prst="rect">
+            <a:avLst/>
+          </a:prstGeom>
+          <a:noFill/>
+        </p:spPr>
+        <p:txBody>
+          <a:bodyPr wrap="square">
+            <a:spAutoFit/>
+          </a:bodyPr>
+          <a:lstStyle/>
+          <a:p>
+            <a:r>
+              <a:rPr sz="1400" b="0">
+                <a:solidFill>
+                  <a:srgbClr val="8B949E"/>
+                </a:solidFill>
+              </a:rPr>
+              <a:t>비유: 학생이 과제를 제출하면 선생님이 채점하고, 별로면 고쳐오라고 돌려보내는 것</a:t>
+            </a:r>
+          </a:p>
+        </p:txBody>
+      </p:sp>
+      <p:sp>
+        <p:nvSpPr>
+          <p:cNvPr id="5" name="Rectangle 4"/>
           <p:cNvSpPr/>
           <p:nvPr/>
         </p:nvSpPr>
         <p:spPr>
           <a:xfrm>
-            <a:off x="914400" y="1005840"/>
-            <a:ext cx="6858000" cy="621792"/>
+            <a:off x="274320" y="1554480"/>
+            <a:ext cx="1920240" cy="2743200"/>
+          </a:xfrm>
+          <a:prstGeom prst="rect">
+            <a:avLst/>
+          </a:prstGeom>
+          <a:solidFill>
+            <a:srgbClr val="161B22"/>
+          </a:solidFill>
+          <a:ln w="19050">
+            <a:solidFill>
+              <a:srgbClr val="58A6FF"/>
+            </a:solidFill>
+          </a:ln>
+        </p:spPr>
+        <p:style>
+          <a:lnRef idx="1">
+            <a:schemeClr val="accent1"/>
+          </a:lnRef>
+          <a:fillRef idx="3">
+            <a:schemeClr val="accent1"/>
+          </a:fillRef>
+          <a:effectRef idx="2">
+            <a:schemeClr val="accent1"/>
+          </a:effectRef>
+          <a:fontRef idx="minor">
+            <a:schemeClr val="lt1"/>
+          </a:fontRef>
+        </p:style>
+        <p:txBody>
+          <a:bodyPr rtlCol="0" anchor="ctr"/>
+          <a:lstStyle/>
+          <a:p>
+            <a:pPr algn="ctr"/>
+          </a:p>
+        </p:txBody>
+      </p:sp>
+      <p:sp>
+        <p:nvSpPr>
+          <p:cNvPr id="6" name="TextBox 5"/>
+          <p:cNvSpPr txBox="1"/>
+          <p:nvPr/>
+        </p:nvSpPr>
+        <p:spPr>
+          <a:xfrm>
+            <a:off x="384048" y="1645920"/>
+            <a:ext cx="1700784" cy="2606040"/>
+          </a:xfrm>
+          <a:prstGeom prst="rect">
+            <a:avLst/>
+          </a:prstGeom>
+          <a:noFill/>
+        </p:spPr>
+        <p:txBody>
+          <a:bodyPr wrap="square">
+            <a:spAutoFit/>
+          </a:bodyPr>
+          <a:lstStyle/>
+          <a:p>
+            <a:r>
+              <a:rPr sz="1300">
+                <a:solidFill>
+                  <a:srgbClr val="FFFFFF"/>
+                </a:solidFill>
+              </a:rPr>
+              <a:t>AI가 보고서 작성
+트렌드 데이터를 보고
+분석 글을 씀</a:t>
+            </a:r>
+          </a:p>
+        </p:txBody>
+      </p:sp>
+      <p:sp>
+        <p:nvSpPr>
+          <p:cNvPr id="7" name="Rectangle 6"/>
+          <p:cNvSpPr/>
+          <p:nvPr/>
+        </p:nvSpPr>
+        <p:spPr>
+          <a:xfrm>
+            <a:off x="2441448" y="1554480"/>
+            <a:ext cx="1920240" cy="2743200"/>
+          </a:xfrm>
+          <a:prstGeom prst="rect">
+            <a:avLst/>
+          </a:prstGeom>
+          <a:solidFill>
+            <a:srgbClr val="161B22"/>
+          </a:solidFill>
+          <a:ln w="19050">
+            <a:solidFill>
+              <a:srgbClr val="D29E22"/>
+            </a:solidFill>
+          </a:ln>
+        </p:spPr>
+        <p:style>
+          <a:lnRef idx="1">
+            <a:schemeClr val="accent1"/>
+          </a:lnRef>
+          <a:fillRef idx="3">
+            <a:schemeClr val="accent1"/>
+          </a:fillRef>
+          <a:effectRef idx="2">
+            <a:schemeClr val="accent1"/>
+          </a:effectRef>
+          <a:fontRef idx="minor">
+            <a:schemeClr val="lt1"/>
+          </a:fontRef>
+        </p:style>
+        <p:txBody>
+          <a:bodyPr rtlCol="0" anchor="ctr"/>
+          <a:lstStyle/>
+          <a:p>
+            <a:pPr algn="ctr"/>
+          </a:p>
+        </p:txBody>
+      </p:sp>
+      <p:sp>
+        <p:nvSpPr>
+          <p:cNvPr id="8" name="TextBox 7"/>
+          <p:cNvSpPr txBox="1"/>
+          <p:nvPr/>
+        </p:nvSpPr>
+        <p:spPr>
+          <a:xfrm>
+            <a:off x="2551176" y="1645920"/>
+            <a:ext cx="1700784" cy="2606040"/>
+          </a:xfrm>
+          <a:prstGeom prst="rect">
+            <a:avLst/>
+          </a:prstGeom>
+          <a:noFill/>
+        </p:spPr>
+        <p:txBody>
+          <a:bodyPr wrap="square">
+            <a:spAutoFit/>
+          </a:bodyPr>
+          <a:lstStyle/>
+          <a:p>
+            <a:r>
+              <a:rPr sz="1300">
+                <a:solidFill>
+                  <a:srgbClr val="FFFFFF"/>
+                </a:solidFill>
+              </a:rPr>
+              <a:t>코드가 품질 검사
+체크리스트로
+자동 채점
+(0~100점)</a:t>
+            </a:r>
+          </a:p>
+        </p:txBody>
+      </p:sp>
+      <p:sp>
+        <p:nvSpPr>
+          <p:cNvPr id="9" name="Rectangle 8"/>
+          <p:cNvSpPr/>
+          <p:nvPr/>
+        </p:nvSpPr>
+        <p:spPr>
+          <a:xfrm>
+            <a:off x="4608576" y="1554480"/>
+            <a:ext cx="1920240" cy="2743200"/>
+          </a:xfrm>
+          <a:prstGeom prst="rect">
+            <a:avLst/>
+          </a:prstGeom>
+          <a:solidFill>
+            <a:srgbClr val="161B22"/>
+          </a:solidFill>
+          <a:ln w="19050">
+            <a:solidFill>
+              <a:srgbClr val="F85149"/>
+            </a:solidFill>
+          </a:ln>
+        </p:spPr>
+        <p:style>
+          <a:lnRef idx="1">
+            <a:schemeClr val="accent1"/>
+          </a:lnRef>
+          <a:fillRef idx="3">
+            <a:schemeClr val="accent1"/>
+          </a:fillRef>
+          <a:effectRef idx="2">
+            <a:schemeClr val="accent1"/>
+          </a:effectRef>
+          <a:fontRef idx="minor">
+            <a:schemeClr val="lt1"/>
+          </a:fontRef>
+        </p:style>
+        <p:txBody>
+          <a:bodyPr rtlCol="0" anchor="ctr"/>
+          <a:lstStyle/>
+          <a:p>
+            <a:pPr algn="ctr"/>
+          </a:p>
+        </p:txBody>
+      </p:sp>
+      <p:sp>
+        <p:nvSpPr>
+          <p:cNvPr id="10" name="TextBox 9"/>
+          <p:cNvSpPr txBox="1"/>
+          <p:nvPr/>
+        </p:nvSpPr>
+        <p:spPr>
+          <a:xfrm>
+            <a:off x="4718304" y="1645920"/>
+            <a:ext cx="1700784" cy="2606040"/>
+          </a:xfrm>
+          <a:prstGeom prst="rect">
+            <a:avLst/>
+          </a:prstGeom>
+          <a:noFill/>
+        </p:spPr>
+        <p:txBody>
+          <a:bodyPr wrap="square">
+            <a:spAutoFit/>
+          </a:bodyPr>
+          <a:lstStyle/>
+          <a:p>
+            <a:r>
+              <a:rPr sz="1300">
+                <a:solidFill>
+                  <a:srgbClr val="FFFFFF"/>
+                </a:solidFill>
+              </a:rPr>
+              <a:t>70점 미만이면
+"레포 이름 더 써줘"
+피드백을 붙여서
+다시 작성 요청 (최대 3회)</a:t>
+            </a:r>
+          </a:p>
+        </p:txBody>
+      </p:sp>
+      <p:sp>
+        <p:nvSpPr>
+          <p:cNvPr id="11" name="Rectangle 10"/>
+          <p:cNvSpPr/>
+          <p:nvPr/>
+        </p:nvSpPr>
+        <p:spPr>
+          <a:xfrm>
+            <a:off x="6775704" y="1554480"/>
+            <a:ext cx="1920240" cy="2743200"/>
           </a:xfrm>
           <a:prstGeom prst="rect">
             <a:avLst/>
@@ -4985,14 +5260,14 @@
       </p:sp>
       <p:sp>
         <p:nvSpPr>
-          <p:cNvPr id="5" name="TextBox 4"/>
+          <p:cNvPr id="12" name="TextBox 11"/>
           <p:cNvSpPr txBox="1"/>
           <p:nvPr/>
         </p:nvSpPr>
         <p:spPr>
           <a:xfrm>
-            <a:off x="1005840" y="1078992"/>
-            <a:ext cx="6675120" cy="530352"/>
+            <a:off x="6885432" y="1645920"/>
+            <a:ext cx="1700784" cy="2606040"/>
           </a:xfrm>
           <a:prstGeom prst="rect">
             <a:avLst/>
@@ -5006,71 +5281,29 @@
           <a:lstStyle/>
           <a:p>
             <a:r>
-              <a:rPr sz="1500">
+              <a:rPr sz="1300">
                 <a:solidFill>
                   <a:srgbClr val="FFFFFF"/>
                 </a:solidFill>
               </a:rPr>
-              <a:t>분석 길이  ·  300자 이상  →  20점</a:t>
-            </a:r>
-          </a:p>
-        </p:txBody>
-      </p:sp>
-      <p:sp>
-        <p:nvSpPr>
-          <p:cNvPr id="6" name="Rectangle 5"/>
-          <p:cNvSpPr/>
-          <p:nvPr/>
-        </p:nvSpPr>
-        <p:spPr>
-          <a:xfrm>
-            <a:off x="914400" y="1755648"/>
-            <a:ext cx="6858000" cy="621792"/>
-          </a:xfrm>
-          <a:prstGeom prst="rect">
-            <a:avLst/>
-          </a:prstGeom>
-          <a:solidFill>
-            <a:srgbClr val="161B22"/>
-          </a:solidFill>
-          <a:ln w="19050">
-            <a:solidFill>
-              <a:srgbClr val="3FB950"/>
-            </a:solidFill>
-          </a:ln>
-        </p:spPr>
-        <p:style>
-          <a:lnRef idx="1">
-            <a:schemeClr val="accent1"/>
-          </a:lnRef>
-          <a:fillRef idx="3">
-            <a:schemeClr val="accent1"/>
-          </a:fillRef>
-          <a:effectRef idx="2">
-            <a:schemeClr val="accent1"/>
-          </a:effectRef>
-          <a:fontRef idx="minor">
-            <a:schemeClr val="lt1"/>
-          </a:fontRef>
-        </p:style>
-        <p:txBody>
-          <a:bodyPr rtlCol="0" anchor="ctr"/>
-          <a:lstStyle/>
-          <a:p>
-            <a:pPr algn="ctr"/>
-          </a:p>
-        </p:txBody>
-      </p:sp>
-      <p:sp>
-        <p:nvSpPr>
-          <p:cNvPr id="7" name="TextBox 6"/>
+              <a:t>70점 이상이면
+통과!
+메일이랑 GitHub에
+자동 발송</a:t>
+            </a:r>
+          </a:p>
+        </p:txBody>
+      </p:sp>
+      <p:sp>
+        <p:nvSpPr>
+          <p:cNvPr id="13" name="TextBox 12"/>
           <p:cNvSpPr txBox="1"/>
           <p:nvPr/>
         </p:nvSpPr>
         <p:spPr>
           <a:xfrm>
-            <a:off x="1005840" y="1828800"/>
-            <a:ext cx="6675120" cy="530352"/>
+            <a:off x="457200" y="4480560"/>
+            <a:ext cx="8229600" cy="365760"/>
           </a:xfrm>
           <a:prstGeom prst="rect">
             <a:avLst/>
@@ -5084,324 +5317,12 @@
           <a:lstStyle/>
           <a:p>
             <a:r>
-              <a:rPr sz="1500">
-                <a:solidFill>
-                  <a:srgbClr val="FFFFFF"/>
+              <a:rPr sz="1200" b="0">
+                <a:solidFill>
+                  <a:srgbClr val="8B949E"/>
                 </a:solidFill>
               </a:rPr>
-              <a:t>트렌드 키워드  ·  3개 이상  →  25점</a:t>
-            </a:r>
-          </a:p>
-        </p:txBody>
-      </p:sp>
-      <p:sp>
-        <p:nvSpPr>
-          <p:cNvPr id="8" name="Rectangle 7"/>
-          <p:cNvSpPr/>
-          <p:nvPr/>
-        </p:nvSpPr>
-        <p:spPr>
-          <a:xfrm>
-            <a:off x="914400" y="2505456"/>
-            <a:ext cx="6858000" cy="621792"/>
-          </a:xfrm>
-          <a:prstGeom prst="rect">
-            <a:avLst/>
-          </a:prstGeom>
-          <a:solidFill>
-            <a:srgbClr val="161B22"/>
-          </a:solidFill>
-          <a:ln w="19050">
-            <a:solidFill>
-              <a:srgbClr val="3FB950"/>
-            </a:solidFill>
-          </a:ln>
-        </p:spPr>
-        <p:style>
-          <a:lnRef idx="1">
-            <a:schemeClr val="accent1"/>
-          </a:lnRef>
-          <a:fillRef idx="3">
-            <a:schemeClr val="accent1"/>
-          </a:fillRef>
-          <a:effectRef idx="2">
-            <a:schemeClr val="accent1"/>
-          </a:effectRef>
-          <a:fontRef idx="minor">
-            <a:schemeClr val="lt1"/>
-          </a:fontRef>
-        </p:style>
-        <p:txBody>
-          <a:bodyPr rtlCol="0" anchor="ctr"/>
-          <a:lstStyle/>
-          <a:p>
-            <a:pPr algn="ctr"/>
-          </a:p>
-        </p:txBody>
-      </p:sp>
-      <p:sp>
-        <p:nvSpPr>
-          <p:cNvPr id="9" name="TextBox 8"/>
-          <p:cNvSpPr txBox="1"/>
-          <p:nvPr/>
-        </p:nvSpPr>
-        <p:spPr>
-          <a:xfrm>
-            <a:off x="1005840" y="2578608"/>
-            <a:ext cx="6675120" cy="530352"/>
-          </a:xfrm>
-          <a:prstGeom prst="rect">
-            <a:avLst/>
-          </a:prstGeom>
-          <a:noFill/>
-        </p:spPr>
-        <p:txBody>
-          <a:bodyPr wrap="square">
-            <a:spAutoFit/>
-          </a:bodyPr>
-          <a:lstStyle/>
-          <a:p>
-            <a:r>
-              <a:rPr sz="1500">
-                <a:solidFill>
-                  <a:srgbClr val="FFFFFF"/>
-                </a:solidFill>
-              </a:rPr>
-              <a:t>레포 이름 언급  ·  3개 이상  →  25점</a:t>
-            </a:r>
-          </a:p>
-        </p:txBody>
-      </p:sp>
-      <p:sp>
-        <p:nvSpPr>
-          <p:cNvPr id="10" name="Rectangle 9"/>
-          <p:cNvSpPr/>
-          <p:nvPr/>
-        </p:nvSpPr>
-        <p:spPr>
-          <a:xfrm>
-            <a:off x="914400" y="3255264"/>
-            <a:ext cx="6858000" cy="621792"/>
-          </a:xfrm>
-          <a:prstGeom prst="rect">
-            <a:avLst/>
-          </a:prstGeom>
-          <a:solidFill>
-            <a:srgbClr val="161B22"/>
-          </a:solidFill>
-          <a:ln w="19050">
-            <a:solidFill>
-              <a:srgbClr val="58A6FF"/>
-            </a:solidFill>
-          </a:ln>
-        </p:spPr>
-        <p:style>
-          <a:lnRef idx="1">
-            <a:schemeClr val="accent1"/>
-          </a:lnRef>
-          <a:fillRef idx="3">
-            <a:schemeClr val="accent1"/>
-          </a:fillRef>
-          <a:effectRef idx="2">
-            <a:schemeClr val="accent1"/>
-          </a:effectRef>
-          <a:fontRef idx="minor">
-            <a:schemeClr val="lt1"/>
-          </a:fontRef>
-        </p:style>
-        <p:txBody>
-          <a:bodyPr rtlCol="0" anchor="ctr"/>
-          <a:lstStyle/>
-          <a:p>
-            <a:pPr algn="ctr"/>
-          </a:p>
-        </p:txBody>
-      </p:sp>
-      <p:sp>
-        <p:nvSpPr>
-          <p:cNvPr id="11" name="TextBox 10"/>
-          <p:cNvSpPr txBox="1"/>
-          <p:nvPr/>
-        </p:nvSpPr>
-        <p:spPr>
-          <a:xfrm>
-            <a:off x="1005840" y="3328416"/>
-            <a:ext cx="6675120" cy="530352"/>
-          </a:xfrm>
-          <a:prstGeom prst="rect">
-            <a:avLst/>
-          </a:prstGeom>
-          <a:noFill/>
-        </p:spPr>
-        <p:txBody>
-          <a:bodyPr wrap="square">
-            <a:spAutoFit/>
-          </a:bodyPr>
-          <a:lstStyle/>
-          <a:p>
-            <a:r>
-              <a:rPr sz="1500">
-                <a:solidFill>
-                  <a:srgbClr val="FFFFFF"/>
-                </a:solidFill>
-              </a:rPr>
-              <a:t>인사이트 수  ·  3개 이상  →  15점</a:t>
-            </a:r>
-          </a:p>
-        </p:txBody>
-      </p:sp>
-      <p:sp>
-        <p:nvSpPr>
-          <p:cNvPr id="12" name="Rectangle 11"/>
-          <p:cNvSpPr/>
-          <p:nvPr/>
-        </p:nvSpPr>
-        <p:spPr>
-          <a:xfrm>
-            <a:off x="914400" y="4005072"/>
-            <a:ext cx="6858000" cy="621792"/>
-          </a:xfrm>
-          <a:prstGeom prst="rect">
-            <a:avLst/>
-          </a:prstGeom>
-          <a:solidFill>
-            <a:srgbClr val="161B22"/>
-          </a:solidFill>
-          <a:ln w="19050">
-            <a:solidFill>
-              <a:srgbClr val="58A6FF"/>
-            </a:solidFill>
-          </a:ln>
-        </p:spPr>
-        <p:style>
-          <a:lnRef idx="1">
-            <a:schemeClr val="accent1"/>
-          </a:lnRef>
-          <a:fillRef idx="3">
-            <a:schemeClr val="accent1"/>
-          </a:fillRef>
-          <a:effectRef idx="2">
-            <a:schemeClr val="accent1"/>
-          </a:effectRef>
-          <a:fontRef idx="minor">
-            <a:schemeClr val="lt1"/>
-          </a:fontRef>
-        </p:style>
-        <p:txBody>
-          <a:bodyPr rtlCol="0" anchor="ctr"/>
-          <a:lstStyle/>
-          <a:p>
-            <a:pPr algn="ctr"/>
-          </a:p>
-        </p:txBody>
-      </p:sp>
-      <p:sp>
-        <p:nvSpPr>
-          <p:cNvPr id="13" name="TextBox 12"/>
-          <p:cNvSpPr txBox="1"/>
-          <p:nvPr/>
-        </p:nvSpPr>
-        <p:spPr>
-          <a:xfrm>
-            <a:off x="1005840" y="4078224"/>
-            <a:ext cx="6675120" cy="530352"/>
-          </a:xfrm>
-          <a:prstGeom prst="rect">
-            <a:avLst/>
-          </a:prstGeom>
-          <a:noFill/>
-        </p:spPr>
-        <p:txBody>
-          <a:bodyPr wrap="square">
-            <a:spAutoFit/>
-          </a:bodyPr>
-          <a:lstStyle/>
-          <a:p>
-            <a:r>
-              <a:rPr sz="1500">
-                <a:solidFill>
-                  <a:srgbClr val="FFFFFF"/>
-                </a:solidFill>
-              </a:rPr>
-              <a:t>기술 방향성  ·  키워드 2개↑  →  15점</a:t>
-            </a:r>
-          </a:p>
-        </p:txBody>
-      </p:sp>
-      <p:sp>
-        <p:nvSpPr>
-          <p:cNvPr id="14" name="Rectangle 13"/>
-          <p:cNvSpPr/>
-          <p:nvPr/>
-        </p:nvSpPr>
-        <p:spPr>
-          <a:xfrm>
-            <a:off x="457200" y="4663440"/>
-            <a:ext cx="8229600" cy="347472"/>
-          </a:xfrm>
-          <a:prstGeom prst="rect">
-            <a:avLst/>
-          </a:prstGeom>
-          <a:solidFill>
-            <a:srgbClr val="161B22"/>
-          </a:solidFill>
-          <a:ln w="19050">
-            <a:solidFill>
-              <a:srgbClr val="3FB950"/>
-            </a:solidFill>
-          </a:ln>
-        </p:spPr>
-        <p:style>
-          <a:lnRef idx="1">
-            <a:schemeClr val="accent1"/>
-          </a:lnRef>
-          <a:fillRef idx="3">
-            <a:schemeClr val="accent1"/>
-          </a:fillRef>
-          <a:effectRef idx="2">
-            <a:schemeClr val="accent1"/>
-          </a:effectRef>
-          <a:fontRef idx="minor">
-            <a:schemeClr val="lt1"/>
-          </a:fontRef>
-        </p:style>
-        <p:txBody>
-          <a:bodyPr rtlCol="0" anchor="ctr"/>
-          <a:lstStyle/>
-          <a:p>
-            <a:pPr algn="ctr"/>
-          </a:p>
-        </p:txBody>
-      </p:sp>
-      <p:sp>
-        <p:nvSpPr>
-          <p:cNvPr id="15" name="TextBox 14"/>
-          <p:cNvSpPr txBox="1"/>
-          <p:nvPr/>
-        </p:nvSpPr>
-        <p:spPr>
-          <a:xfrm>
-            <a:off x="548640" y="4736592"/>
-            <a:ext cx="8046720" cy="256032"/>
-          </a:xfrm>
-          <a:prstGeom prst="rect">
-            <a:avLst/>
-          </a:prstGeom>
-          <a:noFill/>
-        </p:spPr>
-        <p:txBody>
-          <a:bodyPr wrap="square">
-            <a:spAutoFit/>
-          </a:bodyPr>
-          <a:lstStyle/>
-          <a:p>
-            <a:r>
-              <a:rPr sz="1300">
-                <a:solidFill>
-                  <a:srgbClr val="FFFFFF"/>
-                </a:solidFill>
-              </a:rPr>
-              <a:t>합계 70점 이상 → 통과 (compare로 진행)   |   70점 미만 → 재생성 (최대 3회)</a:t>
+              <a:t>트렌드가 뭔지는 GitHub API가 판단 / 보고서를 잘 썼는지는 Self-Correction이 판단</a:t>
             </a:r>
           </a:p>
         </p:txBody>
@@ -5495,21 +5416,54 @@
                   <a:srgbClr val="58A6FF"/>
                 </a:solidFill>
               </a:rPr>
-              <a:t>Self-Correction 루프 동작 방식</a:t>
-            </a:r>
-          </a:p>
-        </p:txBody>
-      </p:sp>
-      <p:sp>
-        <p:nvSpPr>
-          <p:cNvPr id="4" name="Rectangle 3"/>
+              <a:t>품질 검사 기준 (체크리스트)</a:t>
+            </a:r>
+          </a:p>
+        </p:txBody>
+      </p:sp>
+      <p:sp>
+        <p:nvSpPr>
+          <p:cNvPr id="4" name="TextBox 3"/>
+          <p:cNvSpPr txBox="1"/>
+          <p:nvPr/>
+        </p:nvSpPr>
+        <p:spPr>
+          <a:xfrm>
+            <a:off x="457200" y="914400"/>
+            <a:ext cx="8229600" cy="365760"/>
+          </a:xfrm>
+          <a:prstGeom prst="rect">
+            <a:avLst/>
+          </a:prstGeom>
+          <a:noFill/>
+        </p:spPr>
+        <p:txBody>
+          <a:bodyPr wrap="square">
+            <a:spAutoFit/>
+          </a:bodyPr>
+          <a:lstStyle/>
+          <a:p>
+            <a:r>
+              <a:rPr sz="1400" b="0">
+                <a:solidFill>
+                  <a:srgbClr val="8B949E"/>
+                </a:solidFill>
+              </a:rPr>
+              <a:t>사람이 미리 정해둔 "좋은 보고서의 조건"을 코드로 만든 것</a:t>
+            </a:r>
+          </a:p>
+        </p:txBody>
+      </p:sp>
+      <p:sp>
+        <p:nvSpPr>
+          <p:cNvPr id="5" name="Rectangle 4"/>
           <p:cNvSpPr/>
           <p:nvPr/>
         </p:nvSpPr>
         <p:spPr>
           <a:xfrm>
-            <a:off x="365760" y="1005840"/>
-            <a:ext cx="8412480" cy="2743200"/>
+            <a:off x="731520" y="1417320"/>
+            <a:ext cx="7680960" cy="566928"/>
           </a:xfrm>
           <a:prstGeom prst="rect">
             <a:avLst/>
@@ -5547,14 +5501,14 @@
       </p:sp>
       <p:sp>
         <p:nvSpPr>
-          <p:cNvPr id="5" name="TextBox 4"/>
+          <p:cNvPr id="6" name="TextBox 5"/>
           <p:cNvSpPr txBox="1"/>
           <p:nvPr/>
         </p:nvSpPr>
         <p:spPr>
           <a:xfrm>
-            <a:off x="457200" y="1078992"/>
-            <a:ext cx="8229600" cy="2651760"/>
+            <a:off x="841248" y="1508760"/>
+            <a:ext cx="7461504" cy="429768"/>
           </a:xfrm>
           <a:prstGeom prst="rect">
             <a:avLst/>
@@ -5573,28 +5527,66 @@
                   <a:srgbClr val="FFFFFF"/>
                 </a:solidFill>
               </a:rPr>
-              <a:t>[시도 1]  점수: 45/100
-  → 분석 짧음 (210자) | 레포 이름 언급 부족 (1개) | 방향성 키워드 부족
-  → 피드백 반영하여 재생성
-[시도 2]  점수: 65/100
-  → 분석 길이 통과 | 트렌드 키워드 부족 (2개) | 방향성 키워드 부족
-  → 피드백 반영하여 재생성
-[시도 3]  점수: 85/100  ✅ 통과
-  → 모든 품질 기준 통과 → compare 노드로 진행</a:t>
-            </a:r>
-          </a:p>
-        </p:txBody>
-      </p:sp>
-      <p:sp>
-        <p:nvSpPr>
-          <p:cNvPr id="6" name="TextBox 5"/>
+              <a:t>20점  |  글자 수 300자 이상  —  너무 짧으면 내용이 없는 것</a:t>
+            </a:r>
+          </a:p>
+        </p:txBody>
+      </p:sp>
+      <p:sp>
+        <p:nvSpPr>
+          <p:cNvPr id="7" name="Rectangle 6"/>
+          <p:cNvSpPr/>
+          <p:nvPr/>
+        </p:nvSpPr>
+        <p:spPr>
+          <a:xfrm>
+            <a:off x="731520" y="2103120"/>
+            <a:ext cx="7680960" cy="566928"/>
+          </a:xfrm>
+          <a:prstGeom prst="rect">
+            <a:avLst/>
+          </a:prstGeom>
+          <a:solidFill>
+            <a:srgbClr val="161B22"/>
+          </a:solidFill>
+          <a:ln w="19050">
+            <a:solidFill>
+              <a:srgbClr val="3FB950"/>
+            </a:solidFill>
+          </a:ln>
+        </p:spPr>
+        <p:style>
+          <a:lnRef idx="1">
+            <a:schemeClr val="accent1"/>
+          </a:lnRef>
+          <a:fillRef idx="3">
+            <a:schemeClr val="accent1"/>
+          </a:fillRef>
+          <a:effectRef idx="2">
+            <a:schemeClr val="accent1"/>
+          </a:effectRef>
+          <a:fontRef idx="minor">
+            <a:schemeClr val="lt1"/>
+          </a:fontRef>
+        </p:style>
+        <p:txBody>
+          <a:bodyPr rtlCol="0" anchor="ctr"/>
+          <a:lstStyle/>
+          <a:p>
+            <a:pPr algn="ctr"/>
+          </a:p>
+        </p:txBody>
+      </p:sp>
+      <p:sp>
+        <p:nvSpPr>
+          <p:cNvPr id="8" name="TextBox 7"/>
           <p:cNvSpPr txBox="1"/>
           <p:nvPr/>
         </p:nvSpPr>
         <p:spPr>
           <a:xfrm>
-            <a:off x="457200" y="3931920"/>
-            <a:ext cx="8229600" cy="822960"/>
+            <a:off x="841248" y="2194560"/>
+            <a:ext cx="7461504" cy="429768"/>
           </a:xfrm>
           <a:prstGeom prst="rect">
             <a:avLst/>
@@ -5608,13 +5600,324 @@
           <a:lstStyle/>
           <a:p>
             <a:r>
-              <a:rPr sz="1400" b="0">
-                <a:solidFill>
-                  <a:srgbClr val="8B949E"/>
+              <a:rPr sz="1300">
+                <a:solidFill>
+                  <a:srgbClr val="FFFFFF"/>
                 </a:solidFill>
               </a:rPr>
-              <a:t>피드백이 있으면 generate 프롬프트에 '이전 피드백: ...' 섹션이 추가되어
-AI가 어디가 부족했는지 알고 다시 생성한다.</a:t>
+              <a:t>25점  |  트렌드 키워드 3개 이상  —  "증가, 급부상, 인기" 같은 말 없으면 분석 아님</a:t>
+            </a:r>
+          </a:p>
+        </p:txBody>
+      </p:sp>
+      <p:sp>
+        <p:nvSpPr>
+          <p:cNvPr id="9" name="Rectangle 8"/>
+          <p:cNvSpPr/>
+          <p:nvPr/>
+        </p:nvSpPr>
+        <p:spPr>
+          <a:xfrm>
+            <a:off x="731520" y="2788920"/>
+            <a:ext cx="7680960" cy="566928"/>
+          </a:xfrm>
+          <a:prstGeom prst="rect">
+            <a:avLst/>
+          </a:prstGeom>
+          <a:solidFill>
+            <a:srgbClr val="161B22"/>
+          </a:solidFill>
+          <a:ln w="19050">
+            <a:solidFill>
+              <a:srgbClr val="3FB950"/>
+            </a:solidFill>
+          </a:ln>
+        </p:spPr>
+        <p:style>
+          <a:lnRef idx="1">
+            <a:schemeClr val="accent1"/>
+          </a:lnRef>
+          <a:fillRef idx="3">
+            <a:schemeClr val="accent1"/>
+          </a:fillRef>
+          <a:effectRef idx="2">
+            <a:schemeClr val="accent1"/>
+          </a:effectRef>
+          <a:fontRef idx="minor">
+            <a:schemeClr val="lt1"/>
+          </a:fontRef>
+        </p:style>
+        <p:txBody>
+          <a:bodyPr rtlCol="0" anchor="ctr"/>
+          <a:lstStyle/>
+          <a:p>
+            <a:pPr algn="ctr"/>
+          </a:p>
+        </p:txBody>
+      </p:sp>
+      <p:sp>
+        <p:nvSpPr>
+          <p:cNvPr id="10" name="TextBox 9"/>
+          <p:cNvSpPr txBox="1"/>
+          <p:nvPr/>
+        </p:nvSpPr>
+        <p:spPr>
+          <a:xfrm>
+            <a:off x="841248" y="2880360"/>
+            <a:ext cx="7461504" cy="429768"/>
+          </a:xfrm>
+          <a:prstGeom prst="rect">
+            <a:avLst/>
+          </a:prstGeom>
+          <a:noFill/>
+        </p:spPr>
+        <p:txBody>
+          <a:bodyPr wrap="square">
+            <a:spAutoFit/>
+          </a:bodyPr>
+          <a:lstStyle/>
+          <a:p>
+            <a:r>
+              <a:rPr sz="1300">
+                <a:solidFill>
+                  <a:srgbClr val="FFFFFF"/>
+                </a:solidFill>
+              </a:rPr>
+              <a:t>25점  |  레포 이름 3개 이상 언급  —  구체적인 프로젝트 없으면 추상적인 말만 한 것</a:t>
+            </a:r>
+          </a:p>
+        </p:txBody>
+      </p:sp>
+      <p:sp>
+        <p:nvSpPr>
+          <p:cNvPr id="11" name="Rectangle 10"/>
+          <p:cNvSpPr/>
+          <p:nvPr/>
+        </p:nvSpPr>
+        <p:spPr>
+          <a:xfrm>
+            <a:off x="731520" y="3474720"/>
+            <a:ext cx="7680960" cy="566928"/>
+          </a:xfrm>
+          <a:prstGeom prst="rect">
+            <a:avLst/>
+          </a:prstGeom>
+          <a:solidFill>
+            <a:srgbClr val="161B22"/>
+          </a:solidFill>
+          <a:ln w="19050">
+            <a:solidFill>
+              <a:srgbClr val="58A6FF"/>
+            </a:solidFill>
+          </a:ln>
+        </p:spPr>
+        <p:style>
+          <a:lnRef idx="1">
+            <a:schemeClr val="accent1"/>
+          </a:lnRef>
+          <a:fillRef idx="3">
+            <a:schemeClr val="accent1"/>
+          </a:fillRef>
+          <a:effectRef idx="2">
+            <a:schemeClr val="accent1"/>
+          </a:effectRef>
+          <a:fontRef idx="minor">
+            <a:schemeClr val="lt1"/>
+          </a:fontRef>
+        </p:style>
+        <p:txBody>
+          <a:bodyPr rtlCol="0" anchor="ctr"/>
+          <a:lstStyle/>
+          <a:p>
+            <a:pPr algn="ctr"/>
+          </a:p>
+        </p:txBody>
+      </p:sp>
+      <p:sp>
+        <p:nvSpPr>
+          <p:cNvPr id="12" name="TextBox 11"/>
+          <p:cNvSpPr txBox="1"/>
+          <p:nvPr/>
+        </p:nvSpPr>
+        <p:spPr>
+          <a:xfrm>
+            <a:off x="841248" y="3566160"/>
+            <a:ext cx="7461504" cy="429768"/>
+          </a:xfrm>
+          <a:prstGeom prst="rect">
+            <a:avLst/>
+          </a:prstGeom>
+          <a:noFill/>
+        </p:spPr>
+        <p:txBody>
+          <a:bodyPr wrap="square">
+            <a:spAutoFit/>
+          </a:bodyPr>
+          <a:lstStyle/>
+          <a:p>
+            <a:r>
+              <a:rPr sz="1300">
+                <a:solidFill>
+                  <a:srgbClr val="FFFFFF"/>
+                </a:solidFill>
+              </a:rPr>
+              <a:t>15점  |  인사이트 3개 이상  —  결론이 충분히 있어야 함</a:t>
+            </a:r>
+          </a:p>
+        </p:txBody>
+      </p:sp>
+      <p:sp>
+        <p:nvSpPr>
+          <p:cNvPr id="13" name="Rectangle 12"/>
+          <p:cNvSpPr/>
+          <p:nvPr/>
+        </p:nvSpPr>
+        <p:spPr>
+          <a:xfrm>
+            <a:off x="731520" y="4160520"/>
+            <a:ext cx="7680960" cy="566928"/>
+          </a:xfrm>
+          <a:prstGeom prst="rect">
+            <a:avLst/>
+          </a:prstGeom>
+          <a:solidFill>
+            <a:srgbClr val="161B22"/>
+          </a:solidFill>
+          <a:ln w="19050">
+            <a:solidFill>
+              <a:srgbClr val="58A6FF"/>
+            </a:solidFill>
+          </a:ln>
+        </p:spPr>
+        <p:style>
+          <a:lnRef idx="1">
+            <a:schemeClr val="accent1"/>
+          </a:lnRef>
+          <a:fillRef idx="3">
+            <a:schemeClr val="accent1"/>
+          </a:fillRef>
+          <a:effectRef idx="2">
+            <a:schemeClr val="accent1"/>
+          </a:effectRef>
+          <a:fontRef idx="minor">
+            <a:schemeClr val="lt1"/>
+          </a:fontRef>
+        </p:style>
+        <p:txBody>
+          <a:bodyPr rtlCol="0" anchor="ctr"/>
+          <a:lstStyle/>
+          <a:p>
+            <a:pPr algn="ctr"/>
+          </a:p>
+        </p:txBody>
+      </p:sp>
+      <p:sp>
+        <p:nvSpPr>
+          <p:cNvPr id="14" name="TextBox 13"/>
+          <p:cNvSpPr txBox="1"/>
+          <p:nvPr/>
+        </p:nvSpPr>
+        <p:spPr>
+          <a:xfrm>
+            <a:off x="841248" y="4251960"/>
+            <a:ext cx="7461504" cy="429768"/>
+          </a:xfrm>
+          <a:prstGeom prst="rect">
+            <a:avLst/>
+          </a:prstGeom>
+          <a:noFill/>
+        </p:spPr>
+        <p:txBody>
+          <a:bodyPr wrap="square">
+            <a:spAutoFit/>
+          </a:bodyPr>
+          <a:lstStyle/>
+          <a:p>
+            <a:r>
+              <a:rPr sz="1300">
+                <a:solidFill>
+                  <a:srgbClr val="FFFFFF"/>
+                </a:solidFill>
+              </a:rPr>
+              <a:t>15점  |  기술 방향성 언급  —  "앞으로 어떻게 될 것" 이 없으면 분석 아님</a:t>
+            </a:r>
+          </a:p>
+        </p:txBody>
+      </p:sp>
+      <p:sp>
+        <p:nvSpPr>
+          <p:cNvPr id="15" name="Rectangle 14"/>
+          <p:cNvSpPr/>
+          <p:nvPr/>
+        </p:nvSpPr>
+        <p:spPr>
+          <a:xfrm>
+            <a:off x="457200" y="4663440"/>
+            <a:ext cx="8229600" cy="320040"/>
+          </a:xfrm>
+          <a:prstGeom prst="rect">
+            <a:avLst/>
+          </a:prstGeom>
+          <a:solidFill>
+            <a:srgbClr val="161B22"/>
+          </a:solidFill>
+          <a:ln w="19050">
+            <a:solidFill>
+              <a:srgbClr val="3FB950"/>
+            </a:solidFill>
+          </a:ln>
+        </p:spPr>
+        <p:style>
+          <a:lnRef idx="1">
+            <a:schemeClr val="accent1"/>
+          </a:lnRef>
+          <a:fillRef idx="3">
+            <a:schemeClr val="accent1"/>
+          </a:fillRef>
+          <a:effectRef idx="2">
+            <a:schemeClr val="accent1"/>
+          </a:effectRef>
+          <a:fontRef idx="minor">
+            <a:schemeClr val="lt1"/>
+          </a:fontRef>
+        </p:style>
+        <p:txBody>
+          <a:bodyPr rtlCol="0" anchor="ctr"/>
+          <a:lstStyle/>
+          <a:p>
+            <a:pPr algn="ctr"/>
+          </a:p>
+        </p:txBody>
+      </p:sp>
+      <p:sp>
+        <p:nvSpPr>
+          <p:cNvPr id="16" name="TextBox 15"/>
+          <p:cNvSpPr txBox="1"/>
+          <p:nvPr/>
+        </p:nvSpPr>
+        <p:spPr>
+          <a:xfrm>
+            <a:off x="566928" y="4754880"/>
+            <a:ext cx="8010144" cy="182880"/>
+          </a:xfrm>
+          <a:prstGeom prst="rect">
+            <a:avLst/>
+          </a:prstGeom>
+          <a:noFill/>
+        </p:spPr>
+        <p:txBody>
+          <a:bodyPr wrap="square">
+            <a:spAutoFit/>
+          </a:bodyPr>
+          <a:lstStyle/>
+          <a:p>
+            <a:r>
+              <a:rPr sz="1300">
+                <a:solidFill>
+                  <a:srgbClr val="FFFFFF"/>
+                </a:solidFill>
+              </a:rPr>
+              <a:t>합계 70점 이상 → 통과   |   70점 미만 → 피드백 붙여서 재작성 (최대 3회)</a:t>
             </a:r>
           </a:p>
         </p:txBody>
@@ -5708,7 +6011,7 @@
                   <a:srgbClr val="58A6FF"/>
                 </a:solidFill>
               </a:rPr>
-              <a:t>구현: notifier.py — Gmail + GitHub README</a:t>
+              <a:t>별로면 어떻게 다시 써?</a:t>
             </a:r>
           </a:p>
         </p:txBody>
@@ -5722,7 +6025,7 @@
         <p:spPr>
           <a:xfrm>
             <a:off x="274320" y="1005840"/>
-            <a:ext cx="4114800" cy="3200400"/>
+            <a:ext cx="2743200" cy="3474720"/>
           </a:xfrm>
           <a:prstGeom prst="rect">
             <a:avLst/>
@@ -5732,7 +6035,7 @@
           </a:solidFill>
           <a:ln w="19050">
             <a:solidFill>
-              <a:srgbClr val="58A6FF"/>
+              <a:srgbClr val="F85149"/>
             </a:solidFill>
           </a:ln>
         </p:spPr>
@@ -5766,8 +6069,8 @@
         </p:nvSpPr>
         <p:spPr>
           <a:xfrm>
-            <a:off x="365760" y="1078992"/>
-            <a:ext cx="3931920" cy="3108960"/>
+            <a:off x="384048" y="1097280"/>
+            <a:ext cx="2523744" cy="3337560"/>
           </a:xfrm>
           <a:prstGeom prst="rect">
             <a:avLst/>
@@ -5781,30 +6084,184 @@
           <a:lstStyle/>
           <a:p>
             <a:r>
-              <a:rPr sz="1300">
+              <a:rPr sz="1200">
                 <a:solidFill>
                   <a:srgbClr val="FFFFFF"/>
                 </a:solidFill>
               </a:rPr>
-              <a:t>Gmail SMTP 발송
-• smtplib.SMTP_SSL('smtp.gmail.com', 465)
-• Google 앱 비밀번호 필요 (일반 비밀번호 X)
-• HTML 이메일: 트렌딩 레포 테이블 + 인사이트 + AI 분석
-• .env: GMAIL_USER + GMAIL_APP_PASSWORD</a:t>
-            </a:r>
-          </a:p>
-        </p:txBody>
-      </p:sp>
-      <p:sp>
-        <p:nvSpPr>
-          <p:cNvPr id="6" name="Rectangle 5"/>
+              <a:t>1번째 시도
+AI 결과: "요즘 AI 관련 프로젝트가 많습니다."
+검사 결과:
+❌ 210자 (300자 미만)
+❌ 프로젝트 이름 1개
+→ 45점 → 탈락</a:t>
+            </a:r>
+          </a:p>
+        </p:txBody>
+      </p:sp>
+      <p:sp>
+        <p:nvSpPr>
+          <p:cNvPr id="6" name="TextBox 5"/>
+          <p:cNvSpPr txBox="1"/>
+          <p:nvPr/>
+        </p:nvSpPr>
+        <p:spPr>
+          <a:xfrm>
+            <a:off x="3108960" y="2194560"/>
+            <a:ext cx="731520" cy="914400"/>
+          </a:xfrm>
+          <a:prstGeom prst="rect">
+            <a:avLst/>
+          </a:prstGeom>
+          <a:noFill/>
+        </p:spPr>
+        <p:txBody>
+          <a:bodyPr wrap="square">
+            <a:spAutoFit/>
+          </a:bodyPr>
+          <a:lstStyle/>
+          <a:p>
+            <a:r>
+              <a:rPr sz="1300" b="0">
+                <a:solidFill>
+                  <a:srgbClr val="D29E22"/>
+                </a:solidFill>
+              </a:rPr>
+              <a:t>→
+피드백
+전달</a:t>
+            </a:r>
+          </a:p>
+        </p:txBody>
+      </p:sp>
+      <p:sp>
+        <p:nvSpPr>
+          <p:cNvPr id="7" name="Rectangle 6"/>
           <p:cNvSpPr/>
           <p:nvPr/>
         </p:nvSpPr>
         <p:spPr>
           <a:xfrm>
-            <a:off x="4754880" y="1005840"/>
-            <a:ext cx="4114800" cy="3200400"/>
+            <a:off x="3931920" y="1005840"/>
+            <a:ext cx="2743200" cy="3474720"/>
+          </a:xfrm>
+          <a:prstGeom prst="rect">
+            <a:avLst/>
+          </a:prstGeom>
+          <a:solidFill>
+            <a:srgbClr val="161B22"/>
+          </a:solidFill>
+          <a:ln w="19050">
+            <a:solidFill>
+              <a:srgbClr val="D29E22"/>
+            </a:solidFill>
+          </a:ln>
+        </p:spPr>
+        <p:style>
+          <a:lnRef idx="1">
+            <a:schemeClr val="accent1"/>
+          </a:lnRef>
+          <a:fillRef idx="3">
+            <a:schemeClr val="accent1"/>
+          </a:fillRef>
+          <a:effectRef idx="2">
+            <a:schemeClr val="accent1"/>
+          </a:effectRef>
+          <a:fontRef idx="minor">
+            <a:schemeClr val="lt1"/>
+          </a:fontRef>
+        </p:style>
+        <p:txBody>
+          <a:bodyPr rtlCol="0" anchor="ctr"/>
+          <a:lstStyle/>
+          <a:p>
+            <a:pPr algn="ctr"/>
+          </a:p>
+        </p:txBody>
+      </p:sp>
+      <p:sp>
+        <p:nvSpPr>
+          <p:cNvPr id="8" name="TextBox 7"/>
+          <p:cNvSpPr txBox="1"/>
+          <p:nvPr/>
+        </p:nvSpPr>
+        <p:spPr>
+          <a:xfrm>
+            <a:off x="4041648" y="1097280"/>
+            <a:ext cx="2523744" cy="3337560"/>
+          </a:xfrm>
+          <a:prstGeom prst="rect">
+            <a:avLst/>
+          </a:prstGeom>
+          <a:noFill/>
+        </p:spPr>
+        <p:txBody>
+          <a:bodyPr wrap="square">
+            <a:spAutoFit/>
+          </a:bodyPr>
+          <a:lstStyle/>
+          <a:p>
+            <a:r>
+              <a:rPr sz="1200">
+                <a:solidFill>
+                  <a:srgbClr val="FFFFFF"/>
+                </a:solidFill>
+              </a:rPr>
+              <a:t>2번째 시도
+AI한테 이렇게 요청:
+"트렌드 분석해줘"
++ "저번에 이게 문제였어:
+  글자 수 짧아, 프로젝트 이름
+  3개 이상 써줘"
+→ AI가 피드백 보고 다시 씀</a:t>
+            </a:r>
+          </a:p>
+        </p:txBody>
+      </p:sp>
+      <p:sp>
+        <p:nvSpPr>
+          <p:cNvPr id="9" name="TextBox 8"/>
+          <p:cNvSpPr txBox="1"/>
+          <p:nvPr/>
+        </p:nvSpPr>
+        <p:spPr>
+          <a:xfrm>
+            <a:off x="6766560" y="2194560"/>
+            <a:ext cx="640080" cy="914400"/>
+          </a:xfrm>
+          <a:prstGeom prst="rect">
+            <a:avLst/>
+          </a:prstGeom>
+          <a:noFill/>
+        </p:spPr>
+        <p:txBody>
+          <a:bodyPr wrap="square">
+            <a:spAutoFit/>
+          </a:bodyPr>
+          <a:lstStyle/>
+          <a:p>
+            <a:r>
+              <a:rPr sz="1300" b="0">
+                <a:solidFill>
+                  <a:srgbClr val="3FB950"/>
+                </a:solidFill>
+              </a:rPr>
+              <a:t>→
+통과!</a:t>
+            </a:r>
+          </a:p>
+        </p:txBody>
+      </p:sp>
+      <p:sp>
+        <p:nvSpPr>
+          <p:cNvPr id="10" name="Rectangle 9"/>
+          <p:cNvSpPr/>
+          <p:nvPr/>
+        </p:nvSpPr>
+        <p:spPr>
+          <a:xfrm>
+            <a:off x="7498079" y="1005840"/>
+            <a:ext cx="1463040" cy="3474720"/>
           </a:xfrm>
           <a:prstGeom prst="rect">
             <a:avLst/>
@@ -5842,14 +6299,14 @@
       </p:sp>
       <p:sp>
         <p:nvSpPr>
-          <p:cNvPr id="7" name="TextBox 6"/>
+          <p:cNvPr id="11" name="TextBox 10"/>
           <p:cNvSpPr txBox="1"/>
           <p:nvPr/>
         </p:nvSpPr>
         <p:spPr>
           <a:xfrm>
-            <a:off x="4846320" y="1078992"/>
-            <a:ext cx="3931920" cy="3108960"/>
+            <a:off x="7607807" y="1097280"/>
+            <a:ext cx="1243584" cy="3337560"/>
           </a:xfrm>
           <a:prstGeom prst="rect">
             <a:avLst/>
@@ -5863,49 +6320,16 @@
           <a:lstStyle/>
           <a:p>
             <a:r>
-              <a:rPr sz="1300">
+              <a:rPr sz="1100">
                 <a:solidFill>
                   <a:srgbClr val="FFFFFF"/>
                 </a:solidFill>
               </a:rPr>
-              <a:t>GitHub README 업로드
-• GitHub API PUT /repos/:owner/:repo/contents/TREND_REPORT.md
-• 파일 없으면 새로 생성, 있으면 SHA 포함하여 업데이트
-• 내용: 트렌딩 레포 + 품질 점수 + Self-Correction 이력
-• .env: GITHUB_TOKEN + GITHUB_TREND_REPO</a:t>
-            </a:r>
-          </a:p>
-        </p:txBody>
-      </p:sp>
-      <p:sp>
-        <p:nvSpPr>
-          <p:cNvPr id="8" name="TextBox 7"/>
-          <p:cNvSpPr txBox="1"/>
-          <p:nvPr/>
-        </p:nvSpPr>
-        <p:spPr>
-          <a:xfrm>
-            <a:off x="457200" y="4389120"/>
-            <a:ext cx="8229600" cy="457200"/>
-          </a:xfrm>
-          <a:prstGeom prst="rect">
-            <a:avLst/>
-          </a:prstGeom>
-          <a:noFill/>
-        </p:spPr>
-        <p:txBody>
-          <a:bodyPr wrap="square">
-            <a:spAutoFit/>
-          </a:bodyPr>
-          <a:lstStyle/>
-          <a:p>
-            <a:r>
-              <a:rPr sz="1300" b="0">
-                <a:solidFill>
-                  <a:srgbClr val="8B949E"/>
-                </a:solidFill>
-              </a:rPr>
-              <a:t>notify 노드는 compare 다음에 실행 → 품질 통과한 결과만 발송된다</a:t>
+              <a:t>결과
+"llm-tool이 3,200개
+스타로 1위..."
+→ 85점 → 통과
+→ 메일+GitHub 발송</a:t>
             </a:r>
           </a:p>
         </p:txBody>
@@ -5999,7 +6423,7 @@
                   <a:srgbClr val="58A6FF"/>
                 </a:solidFill>
               </a:rPr>
-              <a:t>데모 화면 설명</a:t>
+              <a:t>품질 통과 후 자동 발송</a:t>
             </a:r>
           </a:p>
         </p:txBody>
@@ -6012,8 +6436,8 @@
         </p:nvSpPr>
         <p:spPr>
           <a:xfrm>
-            <a:off x="457200" y="1005840"/>
-            <a:ext cx="8229600" cy="621792"/>
+            <a:off x="274320" y="1005840"/>
+            <a:ext cx="4114800" cy="3474720"/>
           </a:xfrm>
           <a:prstGeom prst="rect">
             <a:avLst/>
@@ -6057,8 +6481,8 @@
         </p:nvSpPr>
         <p:spPr>
           <a:xfrm>
-            <a:off x="548640" y="1078992"/>
-            <a:ext cx="8046720" cy="530352"/>
+            <a:off x="384048" y="1097280"/>
+            <a:ext cx="3895344" cy="3337560"/>
           </a:xfrm>
           <a:prstGeom prst="rect">
             <a:avLst/>
@@ -6077,7 +6501,13 @@
                   <a:srgbClr val="FFFFFF"/>
                 </a:solidFill>
               </a:rPr>
-              <a:t>▶ 품질 점수 메트릭  —  AI 품질 점수 / 재생성 횟수 — 상단 5개 메트릭 중 오른쪽 2개</a:t>
+              <a:t>Gmail 자동 발송
+1. Gmail 우체국(smtp.gmail.com)에 접속
+2. 앱 비밀번호로 본인 확인
+3. 분석 결과로 HTML 이메일 만듦
+   (트렌딩 레포 표 + 인사이트
+    + AI 분석 내용)
+4. yoonjuwon0618@gmail.com 으로 발송</a:t>
             </a:r>
           </a:p>
         </p:txBody>
@@ -6090,86 +6520,8 @@
         </p:nvSpPr>
         <p:spPr>
           <a:xfrm>
-            <a:off x="457200" y="1755648"/>
-            <a:ext cx="8229600" cy="621792"/>
-          </a:xfrm>
-          <a:prstGeom prst="rect">
-            <a:avLst/>
-          </a:prstGeom>
-          <a:solidFill>
-            <a:srgbClr val="161B22"/>
-          </a:solidFill>
-          <a:ln w="19050">
-            <a:solidFill>
-              <a:srgbClr val="D29E22"/>
-            </a:solidFill>
-          </a:ln>
-        </p:spPr>
-        <p:style>
-          <a:lnRef idx="1">
-            <a:schemeClr val="accent1"/>
-          </a:lnRef>
-          <a:fillRef idx="3">
-            <a:schemeClr val="accent1"/>
-          </a:fillRef>
-          <a:effectRef idx="2">
-            <a:schemeClr val="accent1"/>
-          </a:effectRef>
-          <a:fontRef idx="minor">
-            <a:schemeClr val="lt1"/>
-          </a:fontRef>
-        </p:style>
-        <p:txBody>
-          <a:bodyPr rtlCol="0" anchor="ctr"/>
-          <a:lstStyle/>
-          <a:p>
-            <a:pPr algn="ctr"/>
-          </a:p>
-        </p:txBody>
-      </p:sp>
-      <p:sp>
-        <p:nvSpPr>
-          <p:cNvPr id="7" name="TextBox 6"/>
-          <p:cNvSpPr txBox="1"/>
-          <p:nvPr/>
-        </p:nvSpPr>
-        <p:spPr>
-          <a:xfrm>
-            <a:off x="548640" y="1828800"/>
-            <a:ext cx="8046720" cy="530352"/>
-          </a:xfrm>
-          <a:prstGeom prst="rect">
-            <a:avLst/>
-          </a:prstGeom>
-          <a:noFill/>
-        </p:spPr>
-        <p:txBody>
-          <a:bodyPr wrap="square">
-            <a:spAutoFit/>
-          </a:bodyPr>
-          <a:lstStyle/>
-          <a:p>
-            <a:r>
-              <a:rPr sz="1300">
-                <a:solidFill>
-                  <a:srgbClr val="FFFFFF"/>
-                </a:solidFill>
-              </a:rPr>
-              <a:t>▶ Self-Correction 이력  —  시도별 점수 + 피드백 타임라인 + 점수 추이 바 차트</a:t>
-            </a:r>
-          </a:p>
-        </p:txBody>
-      </p:sp>
-      <p:sp>
-        <p:nvSpPr>
-          <p:cNvPr id="8" name="Rectangle 7"/>
-          <p:cNvSpPr/>
-          <p:nvPr/>
-        </p:nvSpPr>
-        <p:spPr>
-          <a:xfrm>
-            <a:off x="457200" y="2505456"/>
-            <a:ext cx="8229600" cy="621792"/>
+            <a:off x="4754880" y="1005840"/>
+            <a:ext cx="4114800" cy="3474720"/>
           </a:xfrm>
           <a:prstGeom prst="rect">
             <a:avLst/>
@@ -6207,14 +6559,14 @@
       </p:sp>
       <p:sp>
         <p:nvSpPr>
-          <p:cNvPr id="9" name="TextBox 8"/>
+          <p:cNvPr id="7" name="TextBox 6"/>
           <p:cNvSpPr txBox="1"/>
           <p:nvPr/>
         </p:nvSpPr>
         <p:spPr>
           <a:xfrm>
-            <a:off x="548640" y="2578608"/>
-            <a:ext cx="8046720" cy="530352"/>
+            <a:off x="4864608" y="1097280"/>
+            <a:ext cx="3895344" cy="3337560"/>
           </a:xfrm>
           <a:prstGeom prst="rect">
             <a:avLst/>
@@ -6233,66 +6585,28 @@
                   <a:srgbClr val="FFFFFF"/>
                 </a:solidFill>
               </a:rPr>
-              <a:t>▶ 알림 발송 상태  —  Gmail: success/error | README: success/error — 결과 색상 표시</a:t>
-            </a:r>
-          </a:p>
-        </p:txBody>
-      </p:sp>
-      <p:sp>
-        <p:nvSpPr>
-          <p:cNvPr id="10" name="Rectangle 9"/>
-          <p:cNvSpPr/>
-          <p:nvPr/>
-        </p:nvSpPr>
-        <p:spPr>
-          <a:xfrm>
-            <a:off x="457200" y="3255264"/>
-            <a:ext cx="8229600" cy="621792"/>
-          </a:xfrm>
-          <a:prstGeom prst="rect">
-            <a:avLst/>
-          </a:prstGeom>
-          <a:solidFill>
-            <a:srgbClr val="161B22"/>
-          </a:solidFill>
-          <a:ln w="19050">
-            <a:solidFill>
-              <a:srgbClr val="8B949E"/>
-            </a:solidFill>
-          </a:ln>
-        </p:spPr>
-        <p:style>
-          <a:lnRef idx="1">
-            <a:schemeClr val="accent1"/>
-          </a:lnRef>
-          <a:fillRef idx="3">
-            <a:schemeClr val="accent1"/>
-          </a:fillRef>
-          <a:effectRef idx="2">
-            <a:schemeClr val="accent1"/>
-          </a:effectRef>
-          <a:fontRef idx="minor">
-            <a:schemeClr val="lt1"/>
-          </a:fontRef>
-        </p:style>
-        <p:txBody>
-          <a:bodyPr rtlCol="0" anchor="ctr"/>
-          <a:lstStyle/>
-          <a:p>
-            <a:pPr algn="ctr"/>
-          </a:p>
-        </p:txBody>
-      </p:sp>
-      <p:sp>
-        <p:nvSpPr>
-          <p:cNvPr id="11" name="TextBox 10"/>
+              <a:t>GitHub README 자동 업로드
+1. GitHub API에 접속
+   (GitHub 토큰으로 본인 확인)
+2. trend-reports 레포에
+   TREND_REPORT.md 파일 있어?
+   있으면 → 내용 업데이트
+   없으면 → 새로 만들기
+3. 분석 결과 내용으로 저장 완료</a:t>
+            </a:r>
+          </a:p>
+        </p:txBody>
+      </p:sp>
+      <p:sp>
+        <p:nvSpPr>
+          <p:cNvPr id="8" name="TextBox 7"/>
           <p:cNvSpPr txBox="1"/>
           <p:nvPr/>
         </p:nvSpPr>
         <p:spPr>
           <a:xfrm>
-            <a:off x="548640" y="3328416"/>
-            <a:ext cx="8046720" cy="530352"/>
+            <a:off x="457200" y="4663440"/>
+            <a:ext cx="8229600" cy="320040"/>
           </a:xfrm>
           <a:prstGeom prst="rect">
             <a:avLst/>
@@ -6306,90 +6620,12 @@
           <a:lstStyle/>
           <a:p>
             <a:r>
-              <a:rPr sz="1300">
-                <a:solidFill>
-                  <a:srgbClr val="FFFFFF"/>
+              <a:rPr sz="1300" b="0">
+                <a:solidFill>
+                  <a:srgbClr val="D29E22"/>
                 </a:solidFill>
               </a:rPr>
-              <a:t>▶ 기존 대시보드  —  트렌딩 레포 카드 + 언어 분포 차트 + AI 분석 + 비교 (9주차와 동일)</a:t>
-            </a:r>
-          </a:p>
-        </p:txBody>
-      </p:sp>
-      <p:sp>
-        <p:nvSpPr>
-          <p:cNvPr id="12" name="Rectangle 11"/>
-          <p:cNvSpPr/>
-          <p:nvPr/>
-        </p:nvSpPr>
-        <p:spPr>
-          <a:xfrm>
-            <a:off x="457200" y="4005072"/>
-            <a:ext cx="8229600" cy="621792"/>
-          </a:xfrm>
-          <a:prstGeom prst="rect">
-            <a:avLst/>
-          </a:prstGeom>
-          <a:solidFill>
-            <a:srgbClr val="161B22"/>
-          </a:solidFill>
-          <a:ln w="19050">
-            <a:solidFill>
-              <a:srgbClr val="58A6FF"/>
-            </a:solidFill>
-          </a:ln>
-        </p:spPr>
-        <p:style>
-          <a:lnRef idx="1">
-            <a:schemeClr val="accent1"/>
-          </a:lnRef>
-          <a:fillRef idx="3">
-            <a:schemeClr val="accent1"/>
-          </a:fillRef>
-          <a:effectRef idx="2">
-            <a:schemeClr val="accent1"/>
-          </a:effectRef>
-          <a:fontRef idx="minor">
-            <a:schemeClr val="lt1"/>
-          </a:fontRef>
-        </p:style>
-        <p:txBody>
-          <a:bodyPr rtlCol="0" anchor="ctr"/>
-          <a:lstStyle/>
-          <a:p>
-            <a:pPr algn="ctr"/>
-          </a:p>
-        </p:txBody>
-      </p:sp>
-      <p:sp>
-        <p:nvSpPr>
-          <p:cNvPr id="13" name="TextBox 12"/>
-          <p:cNvSpPr txBox="1"/>
-          <p:nvPr/>
-        </p:nvSpPr>
-        <p:spPr>
-          <a:xfrm>
-            <a:off x="548640" y="4078224"/>
-            <a:ext cx="8046720" cy="530352"/>
-          </a:xfrm>
-          <a:prstGeom prst="rect">
-            <a:avLst/>
-          </a:prstGeom>
-          <a:noFill/>
-        </p:spPr>
-        <p:txBody>
-          <a:bodyPr wrap="square">
-            <a:spAutoFit/>
-          </a:bodyPr>
-          <a:lstStyle/>
-          <a:p>
-            <a:r>
-              <a:rPr sz="1300">
-                <a:solidFill>
-                  <a:srgbClr val="FFFFFF"/>
-                </a:solidFill>
-              </a:rPr>
-              <a:t>▶ 사이드바 기록  —  날짜별 품질 점수 포함하여 이전 분석 이력 표시</a:t>
+              <a:t>핵심: 품질 검사 통과한 보고서만 발송됨 — 별로면 발송 안 됨</a:t>
             </a:r>
           </a:p>
         </p:txBody>
@@ -6483,7 +6719,7 @@
                   <a:srgbClr val="58A6FF"/>
                 </a:solidFill>
               </a:rPr>
-              <a:t>회고 &amp; 다음 주</a:t>
+              <a:t>파일별 역할</a:t>
             </a:r>
           </a:p>
         </p:txBody>
@@ -6496,8 +6732,8 @@
         </p:nvSpPr>
         <p:spPr>
           <a:xfrm>
-            <a:off x="274320" y="1005840"/>
-            <a:ext cx="8595360" cy="2468880"/>
+            <a:off x="457200" y="960120"/>
+            <a:ext cx="8229600" cy="548640"/>
           </a:xfrm>
           <a:prstGeom prst="rect">
             <a:avLst/>
@@ -6541,8 +6777,8 @@
         </p:nvSpPr>
         <p:spPr>
           <a:xfrm>
-            <a:off x="365760" y="1078992"/>
-            <a:ext cx="8412480" cy="2377440"/>
+            <a:off x="566928" y="1051560"/>
+            <a:ext cx="8010144" cy="411480"/>
           </a:xfrm>
           <a:prstGeom prst="rect">
             <a:avLst/>
@@ -6561,12 +6797,7 @@
                   <a:srgbClr val="FFFFFF"/>
                 </a:solidFill>
               </a:rPr>
-              <a:t>이번 주 배운 점
-• Self-Correction = 품질 기준을 코드로 정의 + 조건 분기로 재실행
-• reflect 노드를 분리하면 기준 수정이 generate에 영향 없음
-• 70점 기준: 너무 높으면 무한루프, 너무 낮으면 의미 없음
-• Gmail App Password는 2단계 인증 후 Google에서 발급 필요
-• GitHub API: 파일 업데이트 시 기존 SHA를 함께 전달해야 함</a:t>
+              <a:t>github_tools.py  |  데이터 수집  —  GitHub API에 접속해서 트렌딩 레포 가져옴</a:t>
             </a:r>
           </a:p>
         </p:txBody>
@@ -6579,8 +6810,164 @@
         </p:nvSpPr>
         <p:spPr>
           <a:xfrm>
-            <a:off x="274320" y="3657600"/>
-            <a:ext cx="8595360" cy="1280160"/>
+            <a:off x="457200" y="1627632"/>
+            <a:ext cx="8229600" cy="548640"/>
+          </a:xfrm>
+          <a:prstGeom prst="rect">
+            <a:avLst/>
+          </a:prstGeom>
+          <a:solidFill>
+            <a:srgbClr val="161B22"/>
+          </a:solidFill>
+          <a:ln w="19050">
+            <a:solidFill>
+              <a:srgbClr val="8B949E"/>
+            </a:solidFill>
+          </a:ln>
+        </p:spPr>
+        <p:style>
+          <a:lnRef idx="1">
+            <a:schemeClr val="accent1"/>
+          </a:lnRef>
+          <a:fillRef idx="3">
+            <a:schemeClr val="accent1"/>
+          </a:fillRef>
+          <a:effectRef idx="2">
+            <a:schemeClr val="accent1"/>
+          </a:effectRef>
+          <a:fontRef idx="minor">
+            <a:schemeClr val="lt1"/>
+          </a:fontRef>
+        </p:style>
+        <p:txBody>
+          <a:bodyPr rtlCol="0" anchor="ctr"/>
+          <a:lstStyle/>
+          <a:p>
+            <a:pPr algn="ctr"/>
+          </a:p>
+        </p:txBody>
+      </p:sp>
+      <p:sp>
+        <p:nvSpPr>
+          <p:cNvPr id="7" name="TextBox 6"/>
+          <p:cNvSpPr txBox="1"/>
+          <p:nvPr/>
+        </p:nvSpPr>
+        <p:spPr>
+          <a:xfrm>
+            <a:off x="566928" y="1719072"/>
+            <a:ext cx="8010144" cy="411480"/>
+          </a:xfrm>
+          <a:prstGeom prst="rect">
+            <a:avLst/>
+          </a:prstGeom>
+          <a:noFill/>
+        </p:spPr>
+        <p:txBody>
+          <a:bodyPr wrap="square">
+            <a:spAutoFit/>
+          </a:bodyPr>
+          <a:lstStyle/>
+          <a:p>
+            <a:r>
+              <a:rPr sz="1300">
+                <a:solidFill>
+                  <a:srgbClr val="FFFFFF"/>
+                </a:solidFill>
+              </a:rPr>
+              <a:t>storage.py  |  저장/불러오기  —  분석 결과를 history.json에 저장하고 불러옴</a:t>
+            </a:r>
+          </a:p>
+        </p:txBody>
+      </p:sp>
+      <p:sp>
+        <p:nvSpPr>
+          <p:cNvPr id="8" name="Rectangle 7"/>
+          <p:cNvSpPr/>
+          <p:nvPr/>
+        </p:nvSpPr>
+        <p:spPr>
+          <a:xfrm>
+            <a:off x="457200" y="2295144"/>
+            <a:ext cx="8229600" cy="548640"/>
+          </a:xfrm>
+          <a:prstGeom prst="rect">
+            <a:avLst/>
+          </a:prstGeom>
+          <a:solidFill>
+            <a:srgbClr val="161B22"/>
+          </a:solidFill>
+          <a:ln w="19050">
+            <a:solidFill>
+              <a:srgbClr val="D29E22"/>
+            </a:solidFill>
+          </a:ln>
+        </p:spPr>
+        <p:style>
+          <a:lnRef idx="1">
+            <a:schemeClr val="accent1"/>
+          </a:lnRef>
+          <a:fillRef idx="3">
+            <a:schemeClr val="accent1"/>
+          </a:fillRef>
+          <a:effectRef idx="2">
+            <a:schemeClr val="accent1"/>
+          </a:effectRef>
+          <a:fontRef idx="minor">
+            <a:schemeClr val="lt1"/>
+          </a:fontRef>
+        </p:style>
+        <p:txBody>
+          <a:bodyPr rtlCol="0" anchor="ctr"/>
+          <a:lstStyle/>
+          <a:p>
+            <a:pPr algn="ctr"/>
+          </a:p>
+        </p:txBody>
+      </p:sp>
+      <p:sp>
+        <p:nvSpPr>
+          <p:cNvPr id="9" name="TextBox 8"/>
+          <p:cNvSpPr txBox="1"/>
+          <p:nvPr/>
+        </p:nvSpPr>
+        <p:spPr>
+          <a:xfrm>
+            <a:off x="566928" y="2386584"/>
+            <a:ext cx="8010144" cy="411480"/>
+          </a:xfrm>
+          <a:prstGeom prst="rect">
+            <a:avLst/>
+          </a:prstGeom>
+          <a:noFill/>
+        </p:spPr>
+        <p:txBody>
+          <a:bodyPr wrap="square">
+            <a:spAutoFit/>
+          </a:bodyPr>
+          <a:lstStyle/>
+          <a:p>
+            <a:r>
+              <a:rPr sz="1300">
+                <a:solidFill>
+                  <a:srgbClr val="FFFFFF"/>
+                </a:solidFill>
+              </a:rPr>
+              <a:t>graph.py ⭐  |  전체 흐름 제어  —  7개 노드를 순서대로 연결. Self-Correction 루프 담당 (핵심)</a:t>
+            </a:r>
+          </a:p>
+        </p:txBody>
+      </p:sp>
+      <p:sp>
+        <p:nvSpPr>
+          <p:cNvPr id="10" name="Rectangle 9"/>
+          <p:cNvSpPr/>
+          <p:nvPr/>
+        </p:nvSpPr>
+        <p:spPr>
+          <a:xfrm>
+            <a:off x="457200" y="2962656"/>
+            <a:ext cx="8229600" cy="548640"/>
           </a:xfrm>
           <a:prstGeom prst="rect">
             <a:avLst/>
@@ -6618,14 +7005,14 @@
       </p:sp>
       <p:sp>
         <p:nvSpPr>
-          <p:cNvPr id="7" name="TextBox 6"/>
+          <p:cNvPr id="11" name="TextBox 10"/>
           <p:cNvSpPr txBox="1"/>
           <p:nvPr/>
         </p:nvSpPr>
         <p:spPr>
           <a:xfrm>
-            <a:off x="365760" y="3730752"/>
-            <a:ext cx="8412480" cy="1188720"/>
+            <a:off x="566928" y="3054096"/>
+            <a:ext cx="8010144" cy="411480"/>
           </a:xfrm>
           <a:prstGeom prst="rect">
             <a:avLst/>
@@ -6644,10 +7031,163 @@
                   <a:srgbClr val="FFFFFF"/>
                 </a:solidFill>
               </a:rPr>
-              <a:t>다음 주 (Week 11): Multi-Agent
-• 여러 에이전트가 협력하는 구조
-• 에이전트 A가 에이전트 B에게 작업을 위임
-• Supervisor 패턴: 중앙 관리자가 서브 에이전트 조율</a:t>
+              <a:t>notifier.py  |  발송 담당  —  Gmail 메일 발송 + GitHub 레포에 파일 업로드</a:t>
+            </a:r>
+          </a:p>
+        </p:txBody>
+      </p:sp>
+      <p:sp>
+        <p:nvSpPr>
+          <p:cNvPr id="12" name="Rectangle 11"/>
+          <p:cNvSpPr/>
+          <p:nvPr/>
+        </p:nvSpPr>
+        <p:spPr>
+          <a:xfrm>
+            <a:off x="457200" y="3630168"/>
+            <a:ext cx="8229600" cy="548640"/>
+          </a:xfrm>
+          <a:prstGeom prst="rect">
+            <a:avLst/>
+          </a:prstGeom>
+          <a:solidFill>
+            <a:srgbClr val="161B22"/>
+          </a:solidFill>
+          <a:ln w="19050">
+            <a:solidFill>
+              <a:srgbClr val="58A6FF"/>
+            </a:solidFill>
+          </a:ln>
+        </p:spPr>
+        <p:style>
+          <a:lnRef idx="1">
+            <a:schemeClr val="accent1"/>
+          </a:lnRef>
+          <a:fillRef idx="3">
+            <a:schemeClr val="accent1"/>
+          </a:fillRef>
+          <a:effectRef idx="2">
+            <a:schemeClr val="accent1"/>
+          </a:effectRef>
+          <a:fontRef idx="minor">
+            <a:schemeClr val="lt1"/>
+          </a:fontRef>
+        </p:style>
+        <p:txBody>
+          <a:bodyPr rtlCol="0" anchor="ctr"/>
+          <a:lstStyle/>
+          <a:p>
+            <a:pPr algn="ctr"/>
+          </a:p>
+        </p:txBody>
+      </p:sp>
+      <p:sp>
+        <p:nvSpPr>
+          <p:cNvPr id="13" name="TextBox 12"/>
+          <p:cNvSpPr txBox="1"/>
+          <p:nvPr/>
+        </p:nvSpPr>
+        <p:spPr>
+          <a:xfrm>
+            <a:off x="566928" y="3721608"/>
+            <a:ext cx="8010144" cy="411480"/>
+          </a:xfrm>
+          <a:prstGeom prst="rect">
+            <a:avLst/>
+          </a:prstGeom>
+          <a:noFill/>
+        </p:spPr>
+        <p:txBody>
+          <a:bodyPr wrap="square">
+            <a:spAutoFit/>
+          </a:bodyPr>
+          <a:lstStyle/>
+          <a:p>
+            <a:r>
+              <a:rPr sz="1300">
+                <a:solidFill>
+                  <a:srgbClr val="FFFFFF"/>
+                </a:solidFill>
+              </a:rPr>
+              <a:t>app.py  |  화면 담당  —  브라우저에 보이는 대시보드. 품질 점수 + 이력 표시</a:t>
+            </a:r>
+          </a:p>
+        </p:txBody>
+      </p:sp>
+      <p:sp>
+        <p:nvSpPr>
+          <p:cNvPr id="14" name="Rectangle 13"/>
+          <p:cNvSpPr/>
+          <p:nvPr/>
+        </p:nvSpPr>
+        <p:spPr>
+          <a:xfrm>
+            <a:off x="457200" y="4297680"/>
+            <a:ext cx="8229600" cy="548640"/>
+          </a:xfrm>
+          <a:prstGeom prst="rect">
+            <a:avLst/>
+          </a:prstGeom>
+          <a:solidFill>
+            <a:srgbClr val="161B22"/>
+          </a:solidFill>
+          <a:ln w="19050">
+            <a:solidFill>
+              <a:srgbClr val="8B949E"/>
+            </a:solidFill>
+          </a:ln>
+        </p:spPr>
+        <p:style>
+          <a:lnRef idx="1">
+            <a:schemeClr val="accent1"/>
+          </a:lnRef>
+          <a:fillRef idx="3">
+            <a:schemeClr val="accent1"/>
+          </a:fillRef>
+          <a:effectRef idx="2">
+            <a:schemeClr val="accent1"/>
+          </a:effectRef>
+          <a:fontRef idx="minor">
+            <a:schemeClr val="lt1"/>
+          </a:fontRef>
+        </p:style>
+        <p:txBody>
+          <a:bodyPr rtlCol="0" anchor="ctr"/>
+          <a:lstStyle/>
+          <a:p>
+            <a:pPr algn="ctr"/>
+          </a:p>
+        </p:txBody>
+      </p:sp>
+      <p:sp>
+        <p:nvSpPr>
+          <p:cNvPr id="15" name="TextBox 14"/>
+          <p:cNvSpPr txBox="1"/>
+          <p:nvPr/>
+        </p:nvSpPr>
+        <p:spPr>
+          <a:xfrm>
+            <a:off x="566928" y="4389120"/>
+            <a:ext cx="8010144" cy="411480"/>
+          </a:xfrm>
+          <a:prstGeom prst="rect">
+            <a:avLst/>
+          </a:prstGeom>
+          <a:noFill/>
+        </p:spPr>
+        <p:txBody>
+          <a:bodyPr wrap="square">
+            <a:spAutoFit/>
+          </a:bodyPr>
+          <a:lstStyle/>
+          <a:p>
+            <a:r>
+              <a:rPr sz="1300">
+                <a:solidFill>
+                  <a:srgbClr val="FFFFFF"/>
+                </a:solidFill>
+              </a:rPr>
+              <a:t>.env  |  비밀번호 보관  —  API 키, Gmail 비밀번호, GitHub 토큰 저장</a:t>
             </a:r>
           </a:p>
         </p:txBody>

</xml_diff>